<commit_message>
Atualiza scripts Oracle e evidências com o resultado real da execução no LiveLabs sandbox
Corrige DDL do JSON (virtual columns davam ORA-01747), adiciona fallback relacional para
população, ajusta a view para JSON_VALUE, documenta a credencial AI_CREDENTIAL que
funcionou para o Select AI e o diagnóstico honesto do bloqueio nas chamadas GENERATE.
Atualiza PPTX e README com o link do dashboard publicado no GitHub Pages.

Co-Authored-By: Claude Sonnet 5 <noreply@anthropic.com>
</commit_message>
<xml_diff>
--- a/EC_Sprint_2_1TSCOA_EvidenciasConstrucao_LEITO360_GRUPO61.pptx
+++ b/EC_Sprint_2_1TSCOA_EvidenciasConstrucao_LEITO360_GRUPO61.pptx
@@ -3507,7 +3507,7 @@
                 <a:ea typeface="Calibri" pitchFamily="34" charset="-122"/>
                 <a:cs typeface="Calibri" pitchFamily="34" charset="-120"/>
               </a:rPr>
-              <a:t>Scripts Oracle (DDL relacional/JSON/external table/view/validações)</a:t>
+              <a:t>Execução Oracle (3 formatos + view, 162 registros confirmados no LiveLabs)</a:t>
             </a:r>
             <a:endParaRPr lang="en-US" sz="1200" dirty="0"/>
           </a:p>
@@ -3697,7 +3697,7 @@
                 <a:ea typeface="Calibri" pitchFamily="34" charset="-122"/>
                 <a:cs typeface="Calibri" pitchFamily="34" charset="-120"/>
               </a:rPr>
-              <a:t>Execução Oracle + evidências (depende do ambiente acadêmico do usuário)</a:t>
+              <a:t>Select AI — perfil criado; GENERATE bloqueado por indisponibilidade do OCI GenAI no sandbox</a:t>
             </a:r>
             <a:endParaRPr lang="en-US" sz="1200" dirty="0"/>
           </a:p>
@@ -3734,7 +3734,7 @@
         <p:spPr>
           <a:xfrm>
             <a:off x="7315200" y="3538728"/>
-            <a:ext cx="1170432" cy="219456"/>
+            <a:ext cx="2048256" cy="219456"/>
           </a:xfrm>
           <a:prstGeom prst="roundRect">
             <a:avLst>
@@ -3780,7 +3780,7 @@
                 <a:ea typeface="Calibri" pitchFamily="34" charset="-122"/>
                 <a:cs typeface="Calibri" pitchFamily="34" charset="-120"/>
               </a:rPr>
-              <a:t>40%</a:t>
+              <a:t>70%</a:t>
             </a:r>
             <a:endParaRPr lang="en-US" sz="1100" dirty="0"/>
           </a:p>
@@ -3887,7 +3887,7 @@
                 <a:ea typeface="Calibri" pitchFamily="34" charset="-122"/>
                 <a:cs typeface="Calibri" pitchFamily="34" charset="-120"/>
               </a:rPr>
-              <a:t>Select AI — perfil e perguntas (scripts prontos, seguindo LiveLabs 4222)</a:t>
+              <a:t>Dashboard sem mocks (filtros, mapa, export CSV)</a:t>
             </a:r>
             <a:endParaRPr lang="en-US" sz="1200" dirty="0"/>
           </a:p>
@@ -3924,7 +3924,7 @@
         <p:spPr>
           <a:xfrm>
             <a:off x="7315200" y="4197096"/>
-            <a:ext cx="1755648" cy="219456"/>
+            <a:ext cx="2926080" cy="219456"/>
           </a:xfrm>
           <a:prstGeom prst="roundRect">
             <a:avLst>
@@ -3932,7 +3932,7 @@
             </a:avLst>
           </a:prstGeom>
           <a:solidFill>
-            <a:srgbClr val="F59E0B"/>
+            <a:srgbClr val="14B8A6"/>
           </a:solidFill>
           <a:ln/>
         </p:spPr>
@@ -3964,13 +3964,13 @@
             <a:r>
               <a:rPr lang="en-US" sz="1100" b="1" dirty="0">
                 <a:solidFill>
-                  <a:srgbClr val="F59E0B"/>
-                </a:solidFill>
-                <a:latin typeface="Calibri" pitchFamily="34" charset="0"/>
-                <a:ea typeface="Calibri" pitchFamily="34" charset="-122"/>
-                <a:cs typeface="Calibri" pitchFamily="34" charset="-120"/>
-              </a:rPr>
-              <a:t>60%</a:t>
+                  <a:srgbClr val="14B8A6"/>
+                </a:solidFill>
+                <a:latin typeface="Calibri" pitchFamily="34" charset="0"/>
+                <a:ea typeface="Calibri" pitchFamily="34" charset="-122"/>
+                <a:cs typeface="Calibri" pitchFamily="34" charset="-120"/>
+              </a:rPr>
+              <a:t>100%</a:t>
             </a:r>
             <a:endParaRPr lang="en-US" sz="1100" dirty="0"/>
           </a:p>
@@ -3985,196 +3985,6 @@
         <p:spPr>
           <a:xfrm>
             <a:off x="10881360" y="4151376"/>
-            <a:ext cx="1737360" cy="320040"/>
-          </a:xfrm>
-          <a:prstGeom prst="roundRect">
-            <a:avLst>
-              <a:gd name="adj" fmla="val 48571"/>
-            </a:avLst>
-          </a:prstGeom>
-          <a:solidFill>
-            <a:srgbClr val="1E3A5F">
-              <a:alpha val="80000"/>
-            </a:srgbClr>
-          </a:solidFill>
-          <a:ln w="12700">
-            <a:solidFill>
-              <a:srgbClr val="F59E0B"/>
-            </a:solidFill>
-            <a:prstDash val="solid"/>
-          </a:ln>
-        </p:spPr>
-      </p:sp>
-      <p:sp>
-        <p:nvSpPr>
-          <p:cNvPr id="29" name="Text 27"/>
-          <p:cNvSpPr/>
-          <p:nvPr/>
-        </p:nvSpPr>
-        <p:spPr>
-          <a:xfrm>
-            <a:off x="10881360" y="4151376"/>
-            <a:ext cx="1737360" cy="320040"/>
-          </a:xfrm>
-          <a:prstGeom prst="rect">
-            <a:avLst/>
-          </a:prstGeom>
-          <a:noFill/>
-          <a:ln/>
-        </p:spPr>
-        <p:txBody>
-          <a:bodyPr wrap="square" lIns="0" tIns="0" rIns="0" bIns="0" rtlCol="0" anchor="ctr"/>
-          <a:lstStyle/>
-          <a:p>
-            <a:pPr algn="ctr" indent="0" marL="0">
-              <a:buNone/>
-            </a:pPr>
-            <a:r>
-              <a:rPr lang="en-US" sz="1000" b="1" dirty="0">
-                <a:solidFill>
-                  <a:srgbClr val="F59E0B"/>
-                </a:solidFill>
-                <a:latin typeface="Calibri" pitchFamily="34" charset="0"/>
-                <a:ea typeface="Calibri" pitchFamily="34" charset="-122"/>
-                <a:cs typeface="Calibri" pitchFamily="34" charset="-120"/>
-              </a:rPr>
-              <a:t>Parcial</a:t>
-            </a:r>
-            <a:endParaRPr lang="en-US" sz="1000" dirty="0"/>
-          </a:p>
-        </p:txBody>
-      </p:sp>
-      <p:sp>
-        <p:nvSpPr>
-          <p:cNvPr id="30" name="Text 28"/>
-          <p:cNvSpPr/>
-          <p:nvPr/>
-        </p:nvSpPr>
-        <p:spPr>
-          <a:xfrm>
-            <a:off x="457200" y="4782312"/>
-            <a:ext cx="6675120" cy="365760"/>
-          </a:xfrm>
-          <a:prstGeom prst="rect">
-            <a:avLst/>
-          </a:prstGeom>
-          <a:noFill/>
-          <a:ln/>
-        </p:spPr>
-        <p:txBody>
-          <a:bodyPr wrap="square" lIns="0" tIns="0" rIns="0" bIns="0" rtlCol="0" anchor="ctr"/>
-          <a:lstStyle/>
-          <a:p>
-            <a:pPr indent="0" marL="0">
-              <a:buNone/>
-            </a:pPr>
-            <a:r>
-              <a:rPr lang="en-US" sz="1200" dirty="0">
-                <a:solidFill>
-                  <a:srgbClr val="EAF6F3"/>
-                </a:solidFill>
-                <a:latin typeface="Calibri" pitchFamily="34" charset="0"/>
-                <a:ea typeface="Calibri" pitchFamily="34" charset="-122"/>
-                <a:cs typeface="Calibri" pitchFamily="34" charset="-120"/>
-              </a:rPr>
-              <a:t>Dashboard sem mocks (filtros, mapa, export CSV)</a:t>
-            </a:r>
-            <a:endParaRPr lang="en-US" sz="1200" dirty="0"/>
-          </a:p>
-        </p:txBody>
-      </p:sp>
-      <p:sp>
-        <p:nvSpPr>
-          <p:cNvPr id="31" name="Shape 29"/>
-          <p:cNvSpPr/>
-          <p:nvPr/>
-        </p:nvSpPr>
-        <p:spPr>
-          <a:xfrm>
-            <a:off x="7315200" y="4855464"/>
-            <a:ext cx="2926080" cy="219456"/>
-          </a:xfrm>
-          <a:prstGeom prst="roundRect">
-            <a:avLst>
-              <a:gd name="adj" fmla="val 20833"/>
-            </a:avLst>
-          </a:prstGeom>
-          <a:solidFill>
-            <a:srgbClr val="1E3A5F"/>
-          </a:solidFill>
-          <a:ln/>
-        </p:spPr>
-      </p:sp>
-      <p:sp>
-        <p:nvSpPr>
-          <p:cNvPr id="32" name="Shape 30"/>
-          <p:cNvSpPr/>
-          <p:nvPr/>
-        </p:nvSpPr>
-        <p:spPr>
-          <a:xfrm>
-            <a:off x="7315200" y="4855464"/>
-            <a:ext cx="2926080" cy="219456"/>
-          </a:xfrm>
-          <a:prstGeom prst="roundRect">
-            <a:avLst>
-              <a:gd name="adj" fmla="val 20833"/>
-            </a:avLst>
-          </a:prstGeom>
-          <a:solidFill>
-            <a:srgbClr val="14B8A6"/>
-          </a:solidFill>
-          <a:ln/>
-        </p:spPr>
-      </p:sp>
-      <p:sp>
-        <p:nvSpPr>
-          <p:cNvPr id="33" name="Text 31"/>
-          <p:cNvSpPr/>
-          <p:nvPr/>
-        </p:nvSpPr>
-        <p:spPr>
-          <a:xfrm>
-            <a:off x="10287000" y="4782312"/>
-            <a:ext cx="548640" cy="365760"/>
-          </a:xfrm>
-          <a:prstGeom prst="rect">
-            <a:avLst/>
-          </a:prstGeom>
-          <a:noFill/>
-          <a:ln/>
-        </p:spPr>
-        <p:txBody>
-          <a:bodyPr wrap="square" lIns="0" tIns="0" rIns="0" bIns="0" rtlCol="0" anchor="ctr"/>
-          <a:lstStyle/>
-          <a:p>
-            <a:pPr indent="0" marL="0">
-              <a:buNone/>
-            </a:pPr>
-            <a:r>
-              <a:rPr lang="en-US" sz="1100" b="1" dirty="0">
-                <a:solidFill>
-                  <a:srgbClr val="14B8A6"/>
-                </a:solidFill>
-                <a:latin typeface="Calibri" pitchFamily="34" charset="0"/>
-                <a:ea typeface="Calibri" pitchFamily="34" charset="-122"/>
-                <a:cs typeface="Calibri" pitchFamily="34" charset="-120"/>
-              </a:rPr>
-              <a:t>100%</a:t>
-            </a:r>
-            <a:endParaRPr lang="en-US" sz="1100" dirty="0"/>
-          </a:p>
-        </p:txBody>
-      </p:sp>
-      <p:sp>
-        <p:nvSpPr>
-          <p:cNvPr id="34" name="Shape 32"/>
-          <p:cNvSpPr/>
-          <p:nvPr/>
-        </p:nvSpPr>
-        <p:spPr>
-          <a:xfrm>
-            <a:off x="10881360" y="4809744"/>
             <a:ext cx="1737360" cy="320040"/>
           </a:xfrm>
           <a:prstGeom prst="roundRect">
@@ -4197,7 +4007,168 @@
       </p:sp>
       <p:sp>
         <p:nvSpPr>
-          <p:cNvPr id="35" name="Text 33"/>
+          <p:cNvPr id="29" name="Text 27"/>
+          <p:cNvSpPr/>
+          <p:nvPr/>
+        </p:nvSpPr>
+        <p:spPr>
+          <a:xfrm>
+            <a:off x="10881360" y="4151376"/>
+            <a:ext cx="1737360" cy="320040"/>
+          </a:xfrm>
+          <a:prstGeom prst="rect">
+            <a:avLst/>
+          </a:prstGeom>
+          <a:noFill/>
+          <a:ln/>
+        </p:spPr>
+        <p:txBody>
+          <a:bodyPr wrap="square" lIns="0" tIns="0" rIns="0" bIns="0" rtlCol="0" anchor="ctr"/>
+          <a:lstStyle/>
+          <a:p>
+            <a:pPr algn="ctr" indent="0" marL="0">
+              <a:buNone/>
+            </a:pPr>
+            <a:r>
+              <a:rPr lang="en-US" sz="1000" b="1" dirty="0">
+                <a:solidFill>
+                  <a:srgbClr val="14B8A6"/>
+                </a:solidFill>
+                <a:latin typeface="Calibri" pitchFamily="34" charset="0"/>
+                <a:ea typeface="Calibri" pitchFamily="34" charset="-122"/>
+                <a:cs typeface="Calibri" pitchFamily="34" charset="-120"/>
+              </a:rPr>
+              <a:t>Implementado</a:t>
+            </a:r>
+            <a:endParaRPr lang="en-US" sz="1000" dirty="0"/>
+          </a:p>
+        </p:txBody>
+      </p:sp>
+      <p:sp>
+        <p:nvSpPr>
+          <p:cNvPr id="30" name="Text 28"/>
+          <p:cNvSpPr/>
+          <p:nvPr/>
+        </p:nvSpPr>
+        <p:spPr>
+          <a:xfrm>
+            <a:off x="457200" y="4782312"/>
+            <a:ext cx="6675120" cy="365760"/>
+          </a:xfrm>
+          <a:prstGeom prst="rect">
+            <a:avLst/>
+          </a:prstGeom>
+          <a:noFill/>
+          <a:ln/>
+        </p:spPr>
+        <p:txBody>
+          <a:bodyPr wrap="square" lIns="0" tIns="0" rIns="0" bIns="0" rtlCol="0" anchor="ctr"/>
+          <a:lstStyle/>
+          <a:p>
+            <a:pPr indent="0" marL="0">
+              <a:buNone/>
+            </a:pPr>
+            <a:r>
+              <a:rPr lang="en-US" sz="1200" dirty="0">
+                <a:solidFill>
+                  <a:srgbClr val="EAF6F3"/>
+                </a:solidFill>
+                <a:latin typeface="Calibri" pitchFamily="34" charset="0"/>
+                <a:ea typeface="Calibri" pitchFamily="34" charset="-122"/>
+                <a:cs typeface="Calibri" pitchFamily="34" charset="-120"/>
+              </a:rPr>
+              <a:t>Publicação (GitHub público + GitHub Pages ao vivo)</a:t>
+            </a:r>
+            <a:endParaRPr lang="en-US" sz="1200" dirty="0"/>
+          </a:p>
+        </p:txBody>
+      </p:sp>
+      <p:sp>
+        <p:nvSpPr>
+          <p:cNvPr id="31" name="Shape 29"/>
+          <p:cNvSpPr/>
+          <p:nvPr/>
+        </p:nvSpPr>
+        <p:spPr>
+          <a:xfrm>
+            <a:off x="7315200" y="4855464"/>
+            <a:ext cx="2926080" cy="219456"/>
+          </a:xfrm>
+          <a:prstGeom prst="roundRect">
+            <a:avLst>
+              <a:gd name="adj" fmla="val 20833"/>
+            </a:avLst>
+          </a:prstGeom>
+          <a:solidFill>
+            <a:srgbClr val="1E3A5F"/>
+          </a:solidFill>
+          <a:ln/>
+        </p:spPr>
+      </p:sp>
+      <p:sp>
+        <p:nvSpPr>
+          <p:cNvPr id="32" name="Shape 30"/>
+          <p:cNvSpPr/>
+          <p:nvPr/>
+        </p:nvSpPr>
+        <p:spPr>
+          <a:xfrm>
+            <a:off x="7315200" y="4855464"/>
+            <a:ext cx="2926080" cy="219456"/>
+          </a:xfrm>
+          <a:prstGeom prst="roundRect">
+            <a:avLst>
+              <a:gd name="adj" fmla="val 20833"/>
+            </a:avLst>
+          </a:prstGeom>
+          <a:solidFill>
+            <a:srgbClr val="14B8A6"/>
+          </a:solidFill>
+          <a:ln/>
+        </p:spPr>
+      </p:sp>
+      <p:sp>
+        <p:nvSpPr>
+          <p:cNvPr id="33" name="Text 31"/>
+          <p:cNvSpPr/>
+          <p:nvPr/>
+        </p:nvSpPr>
+        <p:spPr>
+          <a:xfrm>
+            <a:off x="10287000" y="4782312"/>
+            <a:ext cx="548640" cy="365760"/>
+          </a:xfrm>
+          <a:prstGeom prst="rect">
+            <a:avLst/>
+          </a:prstGeom>
+          <a:noFill/>
+          <a:ln/>
+        </p:spPr>
+        <p:txBody>
+          <a:bodyPr wrap="square" lIns="0" tIns="0" rIns="0" bIns="0" rtlCol="0" anchor="ctr"/>
+          <a:lstStyle/>
+          <a:p>
+            <a:pPr indent="0" marL="0">
+              <a:buNone/>
+            </a:pPr>
+            <a:r>
+              <a:rPr lang="en-US" sz="1100" b="1" dirty="0">
+                <a:solidFill>
+                  <a:srgbClr val="14B8A6"/>
+                </a:solidFill>
+                <a:latin typeface="Calibri" pitchFamily="34" charset="0"/>
+                <a:ea typeface="Calibri" pitchFamily="34" charset="-122"/>
+                <a:cs typeface="Calibri" pitchFamily="34" charset="-120"/>
+              </a:rPr>
+              <a:t>100%</a:t>
+            </a:r>
+            <a:endParaRPr lang="en-US" sz="1100" dirty="0"/>
+          </a:p>
+        </p:txBody>
+      </p:sp>
+      <p:sp>
+        <p:nvSpPr>
+          <p:cNvPr id="34" name="Shape 32"/>
           <p:cNvSpPr/>
           <p:nvPr/>
         </p:nvSpPr>
@@ -4206,6 +4177,35 @@
             <a:off x="10881360" y="4809744"/>
             <a:ext cx="1737360" cy="320040"/>
           </a:xfrm>
+          <a:prstGeom prst="roundRect">
+            <a:avLst>
+              <a:gd name="adj" fmla="val 48571"/>
+            </a:avLst>
+          </a:prstGeom>
+          <a:solidFill>
+            <a:srgbClr val="1E3A5F">
+              <a:alpha val="80000"/>
+            </a:srgbClr>
+          </a:solidFill>
+          <a:ln w="12700">
+            <a:solidFill>
+              <a:srgbClr val="14B8A6"/>
+            </a:solidFill>
+            <a:prstDash val="solid"/>
+          </a:ln>
+        </p:spPr>
+      </p:sp>
+      <p:sp>
+        <p:nvSpPr>
+          <p:cNvPr id="35" name="Text 33"/>
+          <p:cNvSpPr/>
+          <p:nvPr/>
+        </p:nvSpPr>
+        <p:spPr>
+          <a:xfrm>
+            <a:off x="10881360" y="4809744"/>
+            <a:ext cx="1737360" cy="320040"/>
+          </a:xfrm>
           <a:prstGeom prst="rect">
             <a:avLst/>
           </a:prstGeom>
@@ -4267,7 +4267,7 @@
                 <a:ea typeface="Calibri" pitchFamily="34" charset="-122"/>
                 <a:cs typeface="Calibri" pitchFamily="34" charset="-120"/>
               </a:rPr>
-              <a:t>Publicação (GitHub público + Pages + vídeo)</a:t>
+              <a:t>Vídeo pitch (produção com outro integrante do grupo)</a:t>
             </a:r>
             <a:endParaRPr lang="en-US" sz="1200" dirty="0"/>
           </a:p>
@@ -7246,7 +7246,7 @@
                 <a:ea typeface="Cambria" pitchFamily="34" charset="-122"/>
                 <a:cs typeface="Cambria" pitchFamily="34" charset="-120"/>
               </a:rPr>
-              <a:t>Evidências visuais — Oracle (tabelas, JSON, external table, view)</a:t>
+              <a:t>Evidências — execução real no Oracle (LiveLabs sandbox #229599)</a:t>
             </a:r>
             <a:endParaRPr lang="en-US" sz="2800" dirty="0"/>
           </a:p>
@@ -7285,83 +7285,896 @@
                 <a:ea typeface="Calibri" pitchFamily="34" charset="-122"/>
                 <a:cs typeface="Calibri" pitchFamily="34" charset="-120"/>
               </a:rPr>
-              <a:t>Capturar após rodar oracle/sql/01 a 06 no ambiente acadêmico. Cada print deve indicar: o que mostra, o que comprova, a fonte e a limitação.</a:t>
+              <a:t>Rodado de verdade em 31/08–01/09/2026, usuário MOVIESTREAM, tenancy C4U04 (India South).</a:t>
             </a:r>
             <a:endParaRPr lang="en-US" sz="1400" dirty="0"/>
           </a:p>
         </p:txBody>
       </p:sp>
-      <p:sp>
-        <p:nvSpPr>
-          <p:cNvPr id="6" name="Shape 4"/>
-          <p:cNvSpPr/>
-          <p:nvPr/>
-        </p:nvSpPr>
-        <p:spPr>
-          <a:xfrm>
-            <a:off x="457200" y="2103120"/>
-            <a:ext cx="5486400" cy="1965960"/>
-          </a:xfrm>
-          <a:prstGeom prst="roundRect">
-            <a:avLst>
-              <a:gd name="adj" fmla="val 2791"/>
-            </a:avLst>
-          </a:prstGeom>
-          <a:solidFill>
-            <a:srgbClr val="060D1E"/>
-          </a:solidFill>
-          <a:ln w="15875">
-            <a:solidFill>
-              <a:srgbClr val="F59E0B"/>
-            </a:solidFill>
-            <a:prstDash val="dash"/>
-          </a:ln>
-        </p:spPr>
-      </p:sp>
-      <p:sp>
-        <p:nvSpPr>
-          <p:cNvPr id="7" name="Text 5"/>
-          <p:cNvSpPr/>
-          <p:nvPr/>
-        </p:nvSpPr>
-        <p:spPr>
-          <a:xfrm>
-            <a:off x="640080" y="2286000"/>
-            <a:ext cx="5120640" cy="1600200"/>
-          </a:xfrm>
-          <a:prstGeom prst="rect">
-            <a:avLst/>
-          </a:prstGeom>
-          <a:noFill/>
-          <a:ln/>
-        </p:spPr>
-        <p:txBody>
-          <a:bodyPr wrap="square" lIns="0" tIns="0" rIns="0" bIns="0" rtlCol="0" anchor="ctr"/>
-          <a:lstStyle/>
-          <a:p>
-            <a:pPr algn="ctr" indent="0" marL="0">
-              <a:buNone/>
-            </a:pPr>
-            <a:r>
-              <a:rPr lang="en-US" sz="1200" b="1" dirty="0">
-                <a:solidFill>
-                  <a:srgbClr val="F59E0B"/>
-                </a:solidFill>
-                <a:latin typeface="Calibri" pitchFamily="34" charset="0"/>
-                <a:ea typeface="Calibri" pitchFamily="34" charset="-122"/>
-                <a:cs typeface="Calibri" pitchFamily="34" charset="-120"/>
-              </a:rPr>
-              <a:t>PRINT PENDENTE
-</a:t>
-            </a:r>
-            <a:endParaRPr lang="en-US" sz="1200" dirty="0"/>
-          </a:p>
-          <a:p>
-            <a:pPr algn="ctr" indent="0" marL="0">
-              <a:buNone/>
-            </a:pPr>
-            <a:r>
-              <a:rPr lang="en-US" sz="1050" dirty="0">
+      <p:graphicFrame>
+        <p:nvGraphicFramePr>
+          <p:cNvPr id="15" name="Table 0"/>
+          <p:cNvGraphicFramePr>
+            <a:graphicFrameLocks noGrp="1"/>
+          </p:cNvGraphicFramePr>
+          <p:nvPr>
+            <p:extLst>
+              <p:ext uri="{D42A27DB-BD31-4B8C-83A1-F6EECF244321}">
+                <p14:modId xmlns:p14="http://schemas.microsoft.com/office/powerpoint/2010/main" val="1579011935"/>
+              </p:ext>
+            </p:extLst>
+          </p:nvPr>
+        </p:nvGraphicFramePr>
+        <p:xfrm>
+          <a:off x="457200" y="2103120"/>
+          <a:ext cx="11247120" cy="3931920"/>
+        </p:xfrm>
+        <a:graphic>
+          <a:graphicData uri="http://schemas.openxmlformats.org/drawingml/2006/table">
+            <a:tbl>
+              <a:tblPr/>
+              <a:tblGrid>
+                <a:gridCol w="5029200"/>
+                <a:gridCol w="6217920"/>
+              </a:tblGrid>
+              <a:tr h="655320">
+                <a:tc>
+                  <a:txBody>
+                    <a:bodyPr/>
+                    <a:lstStyle/>
+                    <a:p>
+                      <a:pPr indent="0" marL="0">
+                        <a:buNone/>
+                      </a:pPr>
+                      <a:r>
+                        <a:rPr lang="en-US" sz="1050" b="1" dirty="0">
+                          <a:solidFill>
+                            <a:srgbClr val="FFFFFF"/>
+                          </a:solidFill>
+                          <a:latin typeface="Calibri" pitchFamily="34" charset="0"/>
+                          <a:ea typeface="Calibri" pitchFamily="34" charset="-122"/>
+                          <a:cs typeface="Calibri" pitchFamily="34" charset="-120"/>
+                        </a:rPr>
+                        <a:t>Verificação</a:t>
+                      </a:r>
+                      <a:endParaRPr lang="en-US" sz="1050" dirty="0">
+                        <a:latin typeface="Calibri" charset="0"/>
+                        <a:ea typeface="Calibri" charset="0"/>
+                        <a:cs typeface="Calibri" charset="0"/>
+                      </a:endParaRPr>
+                    </a:p>
+                  </a:txBody>
+                  <a:tcPr marL="91440" marR="91440" marT="45720" marB="45720">
+                    <a:lnL w="6350" cap="flat" cmpd="sng" algn="ctr">
+                      <a:solidFill>
+                        <a:srgbClr val="1E3A5F"/>
+                      </a:solidFill>
+                      <a:prstDash val="solid"/>
+                      <a:round/>
+                      <a:headEnd type="none" w="med" len="med"/>
+                      <a:tailEnd type="none" w="med" len="med"/>
+                    </a:lnL>
+                    <a:lnR w="6350" cap="flat" cmpd="sng" algn="ctr">
+                      <a:solidFill>
+                        <a:srgbClr val="1E3A5F"/>
+                      </a:solidFill>
+                      <a:prstDash val="solid"/>
+                      <a:round/>
+                      <a:headEnd type="none" w="med" len="med"/>
+                      <a:tailEnd type="none" w="med" len="med"/>
+                    </a:lnR>
+                    <a:lnT w="6350" cap="flat" cmpd="sng" algn="ctr">
+                      <a:solidFill>
+                        <a:srgbClr val="1E3A5F"/>
+                      </a:solidFill>
+                      <a:prstDash val="solid"/>
+                      <a:round/>
+                      <a:headEnd type="none" w="med" len="med"/>
+                      <a:tailEnd type="none" w="med" len="med"/>
+                    </a:lnT>
+                    <a:lnB w="6350" cap="flat" cmpd="sng" algn="ctr">
+                      <a:solidFill>
+                        <a:srgbClr val="1E3A5F"/>
+                      </a:solidFill>
+                      <a:prstDash val="solid"/>
+                      <a:round/>
+                      <a:headEnd type="none" w="med" len="med"/>
+                      <a:tailEnd type="none" w="med" len="med"/>
+                    </a:lnB>
+                    <a:solidFill>
+                      <a:srgbClr val="091832"/>
+                    </a:solidFill>
+                  </a:tcPr>
+                </a:tc>
+                <a:tc>
+                  <a:txBody>
+                    <a:bodyPr/>
+                    <a:lstStyle/>
+                    <a:p>
+                      <a:pPr indent="0" marL="0">
+                        <a:buNone/>
+                      </a:pPr>
+                      <a:r>
+                        <a:rPr lang="en-US" sz="1050" b="1" dirty="0">
+                          <a:solidFill>
+                            <a:srgbClr val="FFFFFF"/>
+                          </a:solidFill>
+                          <a:latin typeface="Calibri" pitchFamily="34" charset="0"/>
+                          <a:ea typeface="Calibri" pitchFamily="34" charset="-122"/>
+                          <a:cs typeface="Calibri" pitchFamily="34" charset="-120"/>
+                        </a:rPr>
+                        <a:t>Resultado real (Oracle)</a:t>
+                      </a:r>
+                      <a:endParaRPr lang="en-US" sz="1050" dirty="0">
+                        <a:latin typeface="Calibri" charset="0"/>
+                        <a:ea typeface="Calibri" charset="0"/>
+                        <a:cs typeface="Calibri" charset="0"/>
+                      </a:endParaRPr>
+                    </a:p>
+                  </a:txBody>
+                  <a:tcPr marL="91440" marR="91440" marT="45720" marB="45720">
+                    <a:lnL w="6350" cap="flat" cmpd="sng" algn="ctr">
+                      <a:solidFill>
+                        <a:srgbClr val="1E3A5F"/>
+                      </a:solidFill>
+                      <a:prstDash val="solid"/>
+                      <a:round/>
+                      <a:headEnd type="none" w="med" len="med"/>
+                      <a:tailEnd type="none" w="med" len="med"/>
+                    </a:lnL>
+                    <a:lnR w="6350" cap="flat" cmpd="sng" algn="ctr">
+                      <a:solidFill>
+                        <a:srgbClr val="1E3A5F"/>
+                      </a:solidFill>
+                      <a:prstDash val="solid"/>
+                      <a:round/>
+                      <a:headEnd type="none" w="med" len="med"/>
+                      <a:tailEnd type="none" w="med" len="med"/>
+                    </a:lnR>
+                    <a:lnT w="6350" cap="flat" cmpd="sng" algn="ctr">
+                      <a:solidFill>
+                        <a:srgbClr val="1E3A5F"/>
+                      </a:solidFill>
+                      <a:prstDash val="solid"/>
+                      <a:round/>
+                      <a:headEnd type="none" w="med" len="med"/>
+                      <a:tailEnd type="none" w="med" len="med"/>
+                    </a:lnT>
+                    <a:lnB w="6350" cap="flat" cmpd="sng" algn="ctr">
+                      <a:solidFill>
+                        <a:srgbClr val="1E3A5F"/>
+                      </a:solidFill>
+                      <a:prstDash val="solid"/>
+                      <a:round/>
+                      <a:headEnd type="none" w="med" len="med"/>
+                      <a:tailEnd type="none" w="med" len="med"/>
+                    </a:lnB>
+                    <a:solidFill>
+                      <a:srgbClr val="091832"/>
+                    </a:solidFill>
+                  </a:tcPr>
+                </a:tc>
+              </a:tr>
+              <a:tr h="655320">
+                <a:tc>
+                  <a:txBody>
+                    <a:bodyPr/>
+                    <a:lstStyle/>
+                    <a:p>
+                      <a:pPr indent="0" marL="0">
+                        <a:buNone/>
+                      </a:pPr>
+                      <a:r>
+                        <a:rPr lang="en-US" sz="1050" dirty="0">
+                          <a:solidFill>
+                            <a:srgbClr val="EAF6F3"/>
+                          </a:solidFill>
+                          <a:latin typeface="Calibri" pitchFamily="34" charset="0"/>
+                          <a:ea typeface="Calibri" pitchFamily="34" charset="-122"/>
+                          <a:cs typeface="Calibri" pitchFamily="34" charset="-120"/>
+                        </a:rPr>
+                        <a:t>SELECT COUNT(*) FROM VW_LEITO360_ANALITICO</a:t>
+                      </a:r>
+                      <a:endParaRPr lang="en-US" sz="1050" dirty="0">
+                        <a:latin typeface="Calibri" charset="0"/>
+                        <a:ea typeface="Calibri" charset="0"/>
+                        <a:cs typeface="Calibri" charset="0"/>
+                      </a:endParaRPr>
+                    </a:p>
+                  </a:txBody>
+                  <a:tcPr marL="91440" marR="91440" marT="45720" marB="45720" anchor="ctr">
+                    <a:lnL w="6350" cap="flat" cmpd="sng" algn="ctr">
+                      <a:solidFill>
+                        <a:srgbClr val="1E3A5F"/>
+                      </a:solidFill>
+                      <a:prstDash val="solid"/>
+                      <a:round/>
+                      <a:headEnd type="none" w="med" len="med"/>
+                      <a:tailEnd type="none" w="med" len="med"/>
+                    </a:lnL>
+                    <a:lnR w="6350" cap="flat" cmpd="sng" algn="ctr">
+                      <a:solidFill>
+                        <a:srgbClr val="1E3A5F"/>
+                      </a:solidFill>
+                      <a:prstDash val="solid"/>
+                      <a:round/>
+                      <a:headEnd type="none" w="med" len="med"/>
+                      <a:tailEnd type="none" w="med" len="med"/>
+                    </a:lnR>
+                    <a:lnT w="6350" cap="flat" cmpd="sng" algn="ctr">
+                      <a:solidFill>
+                        <a:srgbClr val="1E3A5F"/>
+                      </a:solidFill>
+                      <a:prstDash val="solid"/>
+                      <a:round/>
+                      <a:headEnd type="none" w="med" len="med"/>
+                      <a:tailEnd type="none" w="med" len="med"/>
+                    </a:lnT>
+                    <a:lnB w="6350" cap="flat" cmpd="sng" algn="ctr">
+                      <a:solidFill>
+                        <a:srgbClr val="1E3A5F"/>
+                      </a:solidFill>
+                      <a:prstDash val="solid"/>
+                      <a:round/>
+                      <a:headEnd type="none" w="med" len="med"/>
+                      <a:tailEnd type="none" w="med" len="med"/>
+                    </a:lnB>
+                    <a:solidFill>
+                      <a:srgbClr val="0F2A4A"/>
+                    </a:solidFill>
+                  </a:tcPr>
+                </a:tc>
+                <a:tc>
+                  <a:txBody>
+                    <a:bodyPr/>
+                    <a:lstStyle/>
+                    <a:p>
+                      <a:pPr indent="0" marL="0">
+                        <a:buNone/>
+                      </a:pPr>
+                      <a:r>
+                        <a:rPr lang="en-US" sz="1050" dirty="0">
+                          <a:solidFill>
+                            <a:srgbClr val="EAF6F3"/>
+                          </a:solidFill>
+                          <a:latin typeface="Calibri" pitchFamily="34" charset="0"/>
+                          <a:ea typeface="Calibri" pitchFamily="34" charset="-122"/>
+                          <a:cs typeface="Calibri" pitchFamily="34" charset="-120"/>
+                        </a:rPr>
+                        <a:t>162 (27 UFs × 6 competências)</a:t>
+                      </a:r>
+                      <a:endParaRPr lang="en-US" sz="1050" dirty="0">
+                        <a:latin typeface="Calibri" charset="0"/>
+                        <a:ea typeface="Calibri" charset="0"/>
+                        <a:cs typeface="Calibri" charset="0"/>
+                      </a:endParaRPr>
+                    </a:p>
+                  </a:txBody>
+                  <a:tcPr marL="91440" marR="91440" marT="45720" marB="45720" anchor="ctr">
+                    <a:lnL w="6350" cap="flat" cmpd="sng" algn="ctr">
+                      <a:solidFill>
+                        <a:srgbClr val="1E3A5F"/>
+                      </a:solidFill>
+                      <a:prstDash val="solid"/>
+                      <a:round/>
+                      <a:headEnd type="none" w="med" len="med"/>
+                      <a:tailEnd type="none" w="med" len="med"/>
+                    </a:lnL>
+                    <a:lnR w="6350" cap="flat" cmpd="sng" algn="ctr">
+                      <a:solidFill>
+                        <a:srgbClr val="1E3A5F"/>
+                      </a:solidFill>
+                      <a:prstDash val="solid"/>
+                      <a:round/>
+                      <a:headEnd type="none" w="med" len="med"/>
+                      <a:tailEnd type="none" w="med" len="med"/>
+                    </a:lnR>
+                    <a:lnT w="6350" cap="flat" cmpd="sng" algn="ctr">
+                      <a:solidFill>
+                        <a:srgbClr val="1E3A5F"/>
+                      </a:solidFill>
+                      <a:prstDash val="solid"/>
+                      <a:round/>
+                      <a:headEnd type="none" w="med" len="med"/>
+                      <a:tailEnd type="none" w="med" len="med"/>
+                    </a:lnT>
+                    <a:lnB w="6350" cap="flat" cmpd="sng" algn="ctr">
+                      <a:solidFill>
+                        <a:srgbClr val="1E3A5F"/>
+                      </a:solidFill>
+                      <a:prstDash val="solid"/>
+                      <a:round/>
+                      <a:headEnd type="none" w="med" len="med"/>
+                      <a:tailEnd type="none" w="med" len="med"/>
+                    </a:lnB>
+                    <a:solidFill>
+                      <a:srgbClr val="0F2A4A"/>
+                    </a:solidFill>
+                  </a:tcPr>
+                </a:tc>
+              </a:tr>
+              <a:tr h="655320">
+                <a:tc>
+                  <a:txBody>
+                    <a:bodyPr/>
+                    <a:lstStyle/>
+                    <a:p>
+                      <a:pPr indent="0" marL="0">
+                        <a:buNone/>
+                      </a:pPr>
+                      <a:r>
+                        <a:rPr lang="en-US" sz="1050" dirty="0">
+                          <a:solidFill>
+                            <a:srgbClr val="EAF6F3"/>
+                          </a:solidFill>
+                          <a:latin typeface="Calibri" pitchFamily="34" charset="0"/>
+                          <a:ea typeface="Calibri" pitchFamily="34" charset="-122"/>
+                          <a:cs typeface="Calibri" pitchFamily="34" charset="-120"/>
+                        </a:rPr>
+                        <a:t>Documentos JSON válidos (doc IS JSON)</a:t>
+                      </a:r>
+                      <a:endParaRPr lang="en-US" sz="1050" dirty="0">
+                        <a:latin typeface="Calibri" charset="0"/>
+                        <a:ea typeface="Calibri" charset="0"/>
+                        <a:cs typeface="Calibri" charset="0"/>
+                      </a:endParaRPr>
+                    </a:p>
+                  </a:txBody>
+                  <a:tcPr marL="91440" marR="91440" marT="45720" marB="45720" anchor="ctr">
+                    <a:lnL w="6350" cap="flat" cmpd="sng" algn="ctr">
+                      <a:solidFill>
+                        <a:srgbClr val="1E3A5F"/>
+                      </a:solidFill>
+                      <a:prstDash val="solid"/>
+                      <a:round/>
+                      <a:headEnd type="none" w="med" len="med"/>
+                      <a:tailEnd type="none" w="med" len="med"/>
+                    </a:lnL>
+                    <a:lnR w="6350" cap="flat" cmpd="sng" algn="ctr">
+                      <a:solidFill>
+                        <a:srgbClr val="1E3A5F"/>
+                      </a:solidFill>
+                      <a:prstDash val="solid"/>
+                      <a:round/>
+                      <a:headEnd type="none" w="med" len="med"/>
+                      <a:tailEnd type="none" w="med" len="med"/>
+                    </a:lnR>
+                    <a:lnT w="6350" cap="flat" cmpd="sng" algn="ctr">
+                      <a:solidFill>
+                        <a:srgbClr val="1E3A5F"/>
+                      </a:solidFill>
+                      <a:prstDash val="solid"/>
+                      <a:round/>
+                      <a:headEnd type="none" w="med" len="med"/>
+                      <a:tailEnd type="none" w="med" len="med"/>
+                    </a:lnT>
+                    <a:lnB w="6350" cap="flat" cmpd="sng" algn="ctr">
+                      <a:solidFill>
+                        <a:srgbClr val="1E3A5F"/>
+                      </a:solidFill>
+                      <a:prstDash val="solid"/>
+                      <a:round/>
+                      <a:headEnd type="none" w="med" len="med"/>
+                      <a:tailEnd type="none" w="med" len="med"/>
+                    </a:lnB>
+                    <a:solidFill>
+                      <a:srgbClr val="0F2A4A"/>
+                    </a:solidFill>
+                  </a:tcPr>
+                </a:tc>
+                <a:tc>
+                  <a:txBody>
+                    <a:bodyPr/>
+                    <a:lstStyle/>
+                    <a:p>
+                      <a:pPr indent="0" marL="0">
+                        <a:buNone/>
+                      </a:pPr>
+                      <a:r>
+                        <a:rPr lang="en-US" sz="1050" dirty="0">
+                          <a:solidFill>
+                            <a:srgbClr val="EAF6F3"/>
+                          </a:solidFill>
+                          <a:latin typeface="Calibri" pitchFamily="34" charset="0"/>
+                          <a:ea typeface="Calibri" pitchFamily="34" charset="-122"/>
+                          <a:cs typeface="Calibri" pitchFamily="34" charset="-120"/>
+                        </a:rPr>
+                        <a:t>162 / 162</a:t>
+                      </a:r>
+                      <a:endParaRPr lang="en-US" sz="1050" dirty="0">
+                        <a:latin typeface="Calibri" charset="0"/>
+                        <a:ea typeface="Calibri" charset="0"/>
+                        <a:cs typeface="Calibri" charset="0"/>
+                      </a:endParaRPr>
+                    </a:p>
+                  </a:txBody>
+                  <a:tcPr marL="91440" marR="91440" marT="45720" marB="45720" anchor="ctr">
+                    <a:lnL w="6350" cap="flat" cmpd="sng" algn="ctr">
+                      <a:solidFill>
+                        <a:srgbClr val="1E3A5F"/>
+                      </a:solidFill>
+                      <a:prstDash val="solid"/>
+                      <a:round/>
+                      <a:headEnd type="none" w="med" len="med"/>
+                      <a:tailEnd type="none" w="med" len="med"/>
+                    </a:lnL>
+                    <a:lnR w="6350" cap="flat" cmpd="sng" algn="ctr">
+                      <a:solidFill>
+                        <a:srgbClr val="1E3A5F"/>
+                      </a:solidFill>
+                      <a:prstDash val="solid"/>
+                      <a:round/>
+                      <a:headEnd type="none" w="med" len="med"/>
+                      <a:tailEnd type="none" w="med" len="med"/>
+                    </a:lnR>
+                    <a:lnT w="6350" cap="flat" cmpd="sng" algn="ctr">
+                      <a:solidFill>
+                        <a:srgbClr val="1E3A5F"/>
+                      </a:solidFill>
+                      <a:prstDash val="solid"/>
+                      <a:round/>
+                      <a:headEnd type="none" w="med" len="med"/>
+                      <a:tailEnd type="none" w="med" len="med"/>
+                    </a:lnT>
+                    <a:lnB w="6350" cap="flat" cmpd="sng" algn="ctr">
+                      <a:solidFill>
+                        <a:srgbClr val="1E3A5F"/>
+                      </a:solidFill>
+                      <a:prstDash val="solid"/>
+                      <a:round/>
+                      <a:headEnd type="none" w="med" len="med"/>
+                      <a:tailEnd type="none" w="med" len="med"/>
+                    </a:lnB>
+                    <a:solidFill>
+                      <a:srgbClr val="0F2A4A"/>
+                    </a:solidFill>
+                  </a:tcPr>
+                </a:tc>
+              </a:tr>
+              <a:tr h="655320">
+                <a:tc>
+                  <a:txBody>
+                    <a:bodyPr/>
+                    <a:lstStyle/>
+                    <a:p>
+                      <a:pPr indent="0" marL="0">
+                        <a:buNone/>
+                      </a:pPr>
+                      <a:r>
+                        <a:rPr lang="en-US" sz="1050" dirty="0">
+                          <a:solidFill>
+                            <a:srgbClr val="EAF6F3"/>
+                          </a:solidFill>
+                          <a:latin typeface="Calibri" pitchFamily="34" charset="0"/>
+                          <a:ea typeface="Calibri" pitchFamily="34" charset="-122"/>
+                          <a:cs typeface="Calibri" pitchFamily="34" charset="-120"/>
+                        </a:rPr>
+                        <a:t>Soma internações por competência (Oracle x controle)</a:t>
+                      </a:r>
+                      <a:endParaRPr lang="en-US" sz="1050" dirty="0">
+                        <a:latin typeface="Calibri" charset="0"/>
+                        <a:ea typeface="Calibri" charset="0"/>
+                        <a:cs typeface="Calibri" charset="0"/>
+                      </a:endParaRPr>
+                    </a:p>
+                  </a:txBody>
+                  <a:tcPr marL="91440" marR="91440" marT="45720" marB="45720" anchor="ctr">
+                    <a:lnL w="6350" cap="flat" cmpd="sng" algn="ctr">
+                      <a:solidFill>
+                        <a:srgbClr val="1E3A5F"/>
+                      </a:solidFill>
+                      <a:prstDash val="solid"/>
+                      <a:round/>
+                      <a:headEnd type="none" w="med" len="med"/>
+                      <a:tailEnd type="none" w="med" len="med"/>
+                    </a:lnL>
+                    <a:lnR w="6350" cap="flat" cmpd="sng" algn="ctr">
+                      <a:solidFill>
+                        <a:srgbClr val="1E3A5F"/>
+                      </a:solidFill>
+                      <a:prstDash val="solid"/>
+                      <a:round/>
+                      <a:headEnd type="none" w="med" len="med"/>
+                      <a:tailEnd type="none" w="med" len="med"/>
+                    </a:lnR>
+                    <a:lnT w="6350" cap="flat" cmpd="sng" algn="ctr">
+                      <a:solidFill>
+                        <a:srgbClr val="1E3A5F"/>
+                      </a:solidFill>
+                      <a:prstDash val="solid"/>
+                      <a:round/>
+                      <a:headEnd type="none" w="med" len="med"/>
+                      <a:tailEnd type="none" w="med" len="med"/>
+                    </a:lnT>
+                    <a:lnB w="6350" cap="flat" cmpd="sng" algn="ctr">
+                      <a:solidFill>
+                        <a:srgbClr val="1E3A5F"/>
+                      </a:solidFill>
+                      <a:prstDash val="solid"/>
+                      <a:round/>
+                      <a:headEnd type="none" w="med" len="med"/>
+                      <a:tailEnd type="none" w="med" len="med"/>
+                    </a:lnB>
+                    <a:solidFill>
+                      <a:srgbClr val="0F2A4A"/>
+                    </a:solidFill>
+                  </a:tcPr>
+                </a:tc>
+                <a:tc>
+                  <a:txBody>
+                    <a:bodyPr/>
+                    <a:lstStyle/>
+                    <a:p>
+                      <a:pPr indent="0" marL="0">
+                        <a:buNone/>
+                      </a:pPr>
+                      <a:r>
+                        <a:rPr lang="en-US" sz="1050" dirty="0">
+                          <a:solidFill>
+                            <a:srgbClr val="EAF6F3"/>
+                          </a:solidFill>
+                          <a:latin typeface="Calibri" pitchFamily="34" charset="0"/>
+                          <a:ea typeface="Calibri" pitchFamily="34" charset="-122"/>
+                          <a:cs typeface="Calibri" pitchFamily="34" charset="-120"/>
+                        </a:rPr>
+                        <a:t>1.193.539 / 1.162.871 / 1.178.308 / 1.143.546 / 1.256.010 / 1.218.903 — 0 de diferença em todas</a:t>
+                      </a:r>
+                      <a:endParaRPr lang="en-US" sz="1050" dirty="0">
+                        <a:latin typeface="Calibri" charset="0"/>
+                        <a:ea typeface="Calibri" charset="0"/>
+                        <a:cs typeface="Calibri" charset="0"/>
+                      </a:endParaRPr>
+                    </a:p>
+                  </a:txBody>
+                  <a:tcPr marL="91440" marR="91440" marT="45720" marB="45720" anchor="ctr">
+                    <a:lnL w="6350" cap="flat" cmpd="sng" algn="ctr">
+                      <a:solidFill>
+                        <a:srgbClr val="1E3A5F"/>
+                      </a:solidFill>
+                      <a:prstDash val="solid"/>
+                      <a:round/>
+                      <a:headEnd type="none" w="med" len="med"/>
+                      <a:tailEnd type="none" w="med" len="med"/>
+                    </a:lnL>
+                    <a:lnR w="6350" cap="flat" cmpd="sng" algn="ctr">
+                      <a:solidFill>
+                        <a:srgbClr val="1E3A5F"/>
+                      </a:solidFill>
+                      <a:prstDash val="solid"/>
+                      <a:round/>
+                      <a:headEnd type="none" w="med" len="med"/>
+                      <a:tailEnd type="none" w="med" len="med"/>
+                    </a:lnR>
+                    <a:lnT w="6350" cap="flat" cmpd="sng" algn="ctr">
+                      <a:solidFill>
+                        <a:srgbClr val="1E3A5F"/>
+                      </a:solidFill>
+                      <a:prstDash val="solid"/>
+                      <a:round/>
+                      <a:headEnd type="none" w="med" len="med"/>
+                      <a:tailEnd type="none" w="med" len="med"/>
+                    </a:lnT>
+                    <a:lnB w="6350" cap="flat" cmpd="sng" algn="ctr">
+                      <a:solidFill>
+                        <a:srgbClr val="1E3A5F"/>
+                      </a:solidFill>
+                      <a:prstDash val="solid"/>
+                      <a:round/>
+                      <a:headEnd type="none" w="med" len="med"/>
+                      <a:tailEnd type="none" w="med" len="med"/>
+                    </a:lnB>
+                    <a:solidFill>
+                      <a:srgbClr val="0F2A4A"/>
+                    </a:solidFill>
+                  </a:tcPr>
+                </a:tc>
+              </a:tr>
+              <a:tr h="655320">
+                <a:tc>
+                  <a:txBody>
+                    <a:bodyPr/>
+                    <a:lstStyle/>
+                    <a:p>
+                      <a:pPr indent="0" marL="0">
+                        <a:buNone/>
+                      </a:pPr>
+                      <a:r>
+                        <a:rPr lang="en-US" sz="1050" dirty="0">
+                          <a:solidFill>
+                            <a:srgbClr val="EAF6F3"/>
+                          </a:solidFill>
+                          <a:latin typeface="Calibri" pitchFamily="34" charset="0"/>
+                          <a:ea typeface="Calibri" pitchFamily="34" charset="-122"/>
+                          <a:cs typeface="Calibri" pitchFamily="34" charset="-120"/>
+                        </a:rPr>
+                        <a:t>Soma leitos SUS por competência (Oracle x controle)</a:t>
+                      </a:r>
+                      <a:endParaRPr lang="en-US" sz="1050" dirty="0">
+                        <a:latin typeface="Calibri" charset="0"/>
+                        <a:ea typeface="Calibri" charset="0"/>
+                        <a:cs typeface="Calibri" charset="0"/>
+                      </a:endParaRPr>
+                    </a:p>
+                  </a:txBody>
+                  <a:tcPr marL="91440" marR="91440" marT="45720" marB="45720" anchor="ctr">
+                    <a:lnL w="6350" cap="flat" cmpd="sng" algn="ctr">
+                      <a:solidFill>
+                        <a:srgbClr val="1E3A5F"/>
+                      </a:solidFill>
+                      <a:prstDash val="solid"/>
+                      <a:round/>
+                      <a:headEnd type="none" w="med" len="med"/>
+                      <a:tailEnd type="none" w="med" len="med"/>
+                    </a:lnL>
+                    <a:lnR w="6350" cap="flat" cmpd="sng" algn="ctr">
+                      <a:solidFill>
+                        <a:srgbClr val="1E3A5F"/>
+                      </a:solidFill>
+                      <a:prstDash val="solid"/>
+                      <a:round/>
+                      <a:headEnd type="none" w="med" len="med"/>
+                      <a:tailEnd type="none" w="med" len="med"/>
+                    </a:lnR>
+                    <a:lnT w="6350" cap="flat" cmpd="sng" algn="ctr">
+                      <a:solidFill>
+                        <a:srgbClr val="1E3A5F"/>
+                      </a:solidFill>
+                      <a:prstDash val="solid"/>
+                      <a:round/>
+                      <a:headEnd type="none" w="med" len="med"/>
+                      <a:tailEnd type="none" w="med" len="med"/>
+                    </a:lnT>
+                    <a:lnB w="6350" cap="flat" cmpd="sng" algn="ctr">
+                      <a:solidFill>
+                        <a:srgbClr val="1E3A5F"/>
+                      </a:solidFill>
+                      <a:prstDash val="solid"/>
+                      <a:round/>
+                      <a:headEnd type="none" w="med" len="med"/>
+                      <a:tailEnd type="none" w="med" len="med"/>
+                    </a:lnB>
+                    <a:solidFill>
+                      <a:srgbClr val="0F2A4A"/>
+                    </a:solidFill>
+                  </a:tcPr>
+                </a:tc>
+                <a:tc>
+                  <a:txBody>
+                    <a:bodyPr/>
+                    <a:lstStyle/>
+                    <a:p>
+                      <a:pPr indent="0" marL="0">
+                        <a:buNone/>
+                      </a:pPr>
+                      <a:r>
+                        <a:rPr lang="en-US" sz="1050" dirty="0">
+                          <a:solidFill>
+                            <a:srgbClr val="EAF6F3"/>
+                          </a:solidFill>
+                          <a:latin typeface="Calibri" pitchFamily="34" charset="0"/>
+                          <a:ea typeface="Calibri" pitchFamily="34" charset="-122"/>
+                          <a:cs typeface="Calibri" pitchFamily="34" charset="-120"/>
+                        </a:rPr>
+                        <a:t>315.733 / 316.529 / 316.339 / 316.227 / 316.454 / 316.235 — 0 de diferença em todas</a:t>
+                      </a:r>
+                      <a:endParaRPr lang="en-US" sz="1050" dirty="0">
+                        <a:latin typeface="Calibri" charset="0"/>
+                        <a:ea typeface="Calibri" charset="0"/>
+                        <a:cs typeface="Calibri" charset="0"/>
+                      </a:endParaRPr>
+                    </a:p>
+                  </a:txBody>
+                  <a:tcPr marL="91440" marR="91440" marT="45720" marB="45720" anchor="ctr">
+                    <a:lnL w="6350" cap="flat" cmpd="sng" algn="ctr">
+                      <a:solidFill>
+                        <a:srgbClr val="1E3A5F"/>
+                      </a:solidFill>
+                      <a:prstDash val="solid"/>
+                      <a:round/>
+                      <a:headEnd type="none" w="med" len="med"/>
+                      <a:tailEnd type="none" w="med" len="med"/>
+                    </a:lnL>
+                    <a:lnR w="6350" cap="flat" cmpd="sng" algn="ctr">
+                      <a:solidFill>
+                        <a:srgbClr val="1E3A5F"/>
+                      </a:solidFill>
+                      <a:prstDash val="solid"/>
+                      <a:round/>
+                      <a:headEnd type="none" w="med" len="med"/>
+                      <a:tailEnd type="none" w="med" len="med"/>
+                    </a:lnR>
+                    <a:lnT w="6350" cap="flat" cmpd="sng" algn="ctr">
+                      <a:solidFill>
+                        <a:srgbClr val="1E3A5F"/>
+                      </a:solidFill>
+                      <a:prstDash val="solid"/>
+                      <a:round/>
+                      <a:headEnd type="none" w="med" len="med"/>
+                      <a:tailEnd type="none" w="med" len="med"/>
+                    </a:lnT>
+                    <a:lnB w="6350" cap="flat" cmpd="sng" algn="ctr">
+                      <a:solidFill>
+                        <a:srgbClr val="1E3A5F"/>
+                      </a:solidFill>
+                      <a:prstDash val="solid"/>
+                      <a:round/>
+                      <a:headEnd type="none" w="med" len="med"/>
+                      <a:tailEnd type="none" w="med" len="med"/>
+                    </a:lnB>
+                    <a:solidFill>
+                      <a:srgbClr val="0F2A4A"/>
+                    </a:solidFill>
+                  </a:tcPr>
+                </a:tc>
+              </a:tr>
+              <a:tr h="655320">
+                <a:tc>
+                  <a:txBody>
+                    <a:bodyPr/>
+                    <a:lstStyle/>
+                    <a:p>
+                      <a:pPr indent="0" marL="0">
+                        <a:buNone/>
+                      </a:pPr>
+                      <a:r>
+                        <a:rPr lang="en-US" sz="900" dirty="0">
+                          <a:solidFill>
+                            <a:srgbClr val="EAF6F3"/>
+                          </a:solidFill>
+                          <a:latin typeface="Courier New" pitchFamily="34" charset="0"/>
+                          <a:ea typeface="Courier New" pitchFamily="34" charset="-122"/>
+                          <a:cs typeface="Courier New" pitchFamily="34" charset="-120"/>
+                        </a:rPr>
+                        <a:t>Documento JSON de exemplo (SP, abr/2026)</a:t>
+                      </a:r>
+                      <a:endParaRPr lang="en-US" sz="900" dirty="0">
+                        <a:latin typeface="Courier New" charset="0"/>
+                        <a:ea typeface="Courier New" charset="0"/>
+                        <a:cs typeface="Courier New" charset="0"/>
+                      </a:endParaRPr>
+                    </a:p>
+                  </a:txBody>
+                  <a:tcPr marL="91440" marR="91440" marT="45720" marB="45720" anchor="ctr">
+                    <a:lnL w="6350" cap="flat" cmpd="sng" algn="ctr">
+                      <a:solidFill>
+                        <a:srgbClr val="1E3A5F"/>
+                      </a:solidFill>
+                      <a:prstDash val="solid"/>
+                      <a:round/>
+                      <a:headEnd type="none" w="med" len="med"/>
+                      <a:tailEnd type="none" w="med" len="med"/>
+                    </a:lnL>
+                    <a:lnR w="6350" cap="flat" cmpd="sng" algn="ctr">
+                      <a:solidFill>
+                        <a:srgbClr val="1E3A5F"/>
+                      </a:solidFill>
+                      <a:prstDash val="solid"/>
+                      <a:round/>
+                      <a:headEnd type="none" w="med" len="med"/>
+                      <a:tailEnd type="none" w="med" len="med"/>
+                    </a:lnR>
+                    <a:lnT w="6350" cap="flat" cmpd="sng" algn="ctr">
+                      <a:solidFill>
+                        <a:srgbClr val="1E3A5F"/>
+                      </a:solidFill>
+                      <a:prstDash val="solid"/>
+                      <a:round/>
+                      <a:headEnd type="none" w="med" len="med"/>
+                      <a:tailEnd type="none" w="med" len="med"/>
+                    </a:lnT>
+                    <a:lnB w="6350" cap="flat" cmpd="sng" algn="ctr">
+                      <a:solidFill>
+                        <a:srgbClr val="1E3A5F"/>
+                      </a:solidFill>
+                      <a:prstDash val="solid"/>
+                      <a:round/>
+                      <a:headEnd type="none" w="med" len="med"/>
+                      <a:tailEnd type="none" w="med" len="med"/>
+                    </a:lnB>
+                    <a:solidFill>
+                      <a:srgbClr val="0F2A4A"/>
+                    </a:solidFill>
+                  </a:tcPr>
+                </a:tc>
+                <a:tc>
+                  <a:txBody>
+                    <a:bodyPr/>
+                    <a:lstStyle/>
+                    <a:p>
+                      <a:pPr indent="0" marL="0">
+                        <a:buNone/>
+                      </a:pPr>
+                      <a:r>
+                        <a:rPr lang="en-US" sz="900" dirty="0">
+                          <a:solidFill>
+                            <a:srgbClr val="EAF6F3"/>
+                          </a:solidFill>
+                          <a:latin typeface="Courier New" pitchFamily="34" charset="0"/>
+                          <a:ea typeface="Courier New" pitchFamily="34" charset="-122"/>
+                          <a:cs typeface="Courier New" pitchFamily="34" charset="-120"/>
+                        </a:rPr>
+                        <a:t>{"competencia":"2026-04","codigo_uf":"35","sigla_uf":"SP","estado":"São Paulo","regiao":"Sudeste","leitos_sus_cadastrados":54722}</a:t>
+                      </a:r>
+                      <a:endParaRPr lang="en-US" sz="900" dirty="0">
+                        <a:latin typeface="Courier New" charset="0"/>
+                        <a:ea typeface="Courier New" charset="0"/>
+                        <a:cs typeface="Courier New" charset="0"/>
+                      </a:endParaRPr>
+                    </a:p>
+                  </a:txBody>
+                  <a:tcPr marL="91440" marR="91440" marT="45720" marB="45720" anchor="ctr">
+                    <a:lnL w="6350" cap="flat" cmpd="sng" algn="ctr">
+                      <a:solidFill>
+                        <a:srgbClr val="1E3A5F"/>
+                      </a:solidFill>
+                      <a:prstDash val="solid"/>
+                      <a:round/>
+                      <a:headEnd type="none" w="med" len="med"/>
+                      <a:tailEnd type="none" w="med" len="med"/>
+                    </a:lnL>
+                    <a:lnR w="6350" cap="flat" cmpd="sng" algn="ctr">
+                      <a:solidFill>
+                        <a:srgbClr val="1E3A5F"/>
+                      </a:solidFill>
+                      <a:prstDash val="solid"/>
+                      <a:round/>
+                      <a:headEnd type="none" w="med" len="med"/>
+                      <a:tailEnd type="none" w="med" len="med"/>
+                    </a:lnR>
+                    <a:lnT w="6350" cap="flat" cmpd="sng" algn="ctr">
+                      <a:solidFill>
+                        <a:srgbClr val="1E3A5F"/>
+                      </a:solidFill>
+                      <a:prstDash val="solid"/>
+                      <a:round/>
+                      <a:headEnd type="none" w="med" len="med"/>
+                      <a:tailEnd type="none" w="med" len="med"/>
+                    </a:lnT>
+                    <a:lnB w="6350" cap="flat" cmpd="sng" algn="ctr">
+                      <a:solidFill>
+                        <a:srgbClr val="1E3A5F"/>
+                      </a:solidFill>
+                      <a:prstDash val="solid"/>
+                      <a:round/>
+                      <a:headEnd type="none" w="med" len="med"/>
+                      <a:tailEnd type="none" w="med" len="med"/>
+                    </a:lnB>
+                    <a:solidFill>
+                      <a:srgbClr val="0F2A4A"/>
+                    </a:solidFill>
+                  </a:tcPr>
+                </a:tc>
+              </a:tr>
+            </a:tbl>
+          </a:graphicData>
+        </a:graphic>
+      </p:graphicFrame>
+      <p:sp>
+        <p:nvSpPr>
+          <p:cNvPr id="7" name="Text 4"/>
+          <p:cNvSpPr/>
+          <p:nvPr/>
+        </p:nvSpPr>
+        <p:spPr>
+          <a:xfrm>
+            <a:off x="457200" y="6172200"/>
+            <a:ext cx="11247120" cy="320040"/>
+          </a:xfrm>
+          <a:prstGeom prst="rect">
+            <a:avLst/>
+          </a:prstGeom>
+          <a:noFill/>
+          <a:ln/>
+        </p:spPr>
+        <p:txBody>
+          <a:bodyPr wrap="square" lIns="0" tIns="0" rIns="0" bIns="0" rtlCol="0" anchor="ctr"/>
+          <a:lstStyle/>
+          <a:p>
+            <a:pPr indent="0" marL="0">
+              <a:buNone/>
+            </a:pPr>
+            <a:r>
+              <a:rPr lang="en-US" sz="900" i="1" dirty="0">
                 <a:solidFill>
                   <a:srgbClr val="94A3B8"/>
                 </a:solidFill>
@@ -7369,335 +8182,15 @@
                 <a:ea typeface="Calibri" pitchFamily="34" charset="-122"/>
                 <a:cs typeface="Calibri" pitchFamily="34" charset="-120"/>
               </a:rPr>
-              <a:t>Tabela relacional LEITO360_SIH</a:t>
-            </a:r>
-            <a:endParaRPr lang="en-US" sz="1200" dirty="0"/>
-          </a:p>
-          <a:p>
-            <a:pPr algn="ctr" indent="0" marL="0">
-              <a:buNone/>
-            </a:pPr>
-            <a:r>
-              <a:rPr lang="en-US" sz="1050" dirty="0">
-                <a:solidFill>
-                  <a:srgbClr val="94A3B8"/>
-                </a:solidFill>
-                <a:latin typeface="Calibri" pitchFamily="34" charset="0"/>
-                <a:ea typeface="Calibri" pitchFamily="34" charset="-122"/>
-                <a:cs typeface="Calibri" pitchFamily="34" charset="-120"/>
-              </a:rPr>
-              <a:t>(SELECT * + COUNT)</a:t>
-            </a:r>
-            <a:endParaRPr lang="en-US" sz="1200" dirty="0"/>
-          </a:p>
-        </p:txBody>
-      </p:sp>
-      <p:sp>
-        <p:nvSpPr>
-          <p:cNvPr id="8" name="Shape 6"/>
-          <p:cNvSpPr/>
-          <p:nvPr/>
-        </p:nvSpPr>
-        <p:spPr>
-          <a:xfrm>
-            <a:off x="6080760" y="2103120"/>
-            <a:ext cx="5486400" cy="1965960"/>
-          </a:xfrm>
-          <a:prstGeom prst="roundRect">
-            <a:avLst>
-              <a:gd name="adj" fmla="val 2791"/>
-            </a:avLst>
-          </a:prstGeom>
-          <a:solidFill>
-            <a:srgbClr val="060D1E"/>
-          </a:solidFill>
-          <a:ln w="15875">
-            <a:solidFill>
-              <a:srgbClr val="F59E0B"/>
-            </a:solidFill>
-            <a:prstDash val="dash"/>
-          </a:ln>
-        </p:spPr>
-      </p:sp>
-      <p:sp>
-        <p:nvSpPr>
-          <p:cNvPr id="9" name="Text 7"/>
-          <p:cNvSpPr/>
-          <p:nvPr/>
-        </p:nvSpPr>
-        <p:spPr>
-          <a:xfrm>
-            <a:off x="6263640" y="2286000"/>
-            <a:ext cx="5120640" cy="1600200"/>
-          </a:xfrm>
-          <a:prstGeom prst="rect">
-            <a:avLst/>
-          </a:prstGeom>
-          <a:noFill/>
-          <a:ln/>
-        </p:spPr>
-        <p:txBody>
-          <a:bodyPr wrap="square" lIns="0" tIns="0" rIns="0" bIns="0" rtlCol="0" anchor="ctr"/>
-          <a:lstStyle/>
-          <a:p>
-            <a:pPr algn="ctr" indent="0" marL="0">
-              <a:buNone/>
-            </a:pPr>
-            <a:r>
-              <a:rPr lang="en-US" sz="1200" b="1" dirty="0">
-                <a:solidFill>
-                  <a:srgbClr val="F59E0B"/>
-                </a:solidFill>
-                <a:latin typeface="Calibri" pitchFamily="34" charset="0"/>
-                <a:ea typeface="Calibri" pitchFamily="34" charset="-122"/>
-                <a:cs typeface="Calibri" pitchFamily="34" charset="-120"/>
-              </a:rPr>
-              <a:t>PRINT PENDENTE
-</a:t>
-            </a:r>
-            <a:endParaRPr lang="en-US" sz="1200" dirty="0"/>
-          </a:p>
-          <a:p>
-            <a:pPr algn="ctr" indent="0" marL="0">
-              <a:buNone/>
-            </a:pPr>
-            <a:r>
-              <a:rPr lang="en-US" sz="1050" dirty="0">
-                <a:solidFill>
-                  <a:srgbClr val="94A3B8"/>
-                </a:solidFill>
-                <a:latin typeface="Calibri" pitchFamily="34" charset="0"/>
-                <a:ea typeface="Calibri" pitchFamily="34" charset="-122"/>
-                <a:cs typeface="Calibri" pitchFamily="34" charset="-120"/>
-              </a:rPr>
-              <a:t>Documento JSON LEITO360_CNES_JSON</a:t>
-            </a:r>
-            <a:endParaRPr lang="en-US" sz="1200" dirty="0"/>
-          </a:p>
-          <a:p>
-            <a:pPr algn="ctr" indent="0" marL="0">
-              <a:buNone/>
-            </a:pPr>
-            <a:r>
-              <a:rPr lang="en-US" sz="1050" dirty="0">
-                <a:solidFill>
-                  <a:srgbClr val="94A3B8"/>
-                </a:solidFill>
-                <a:latin typeface="Calibri" pitchFamily="34" charset="0"/>
-                <a:ea typeface="Calibri" pitchFamily="34" charset="-122"/>
-                <a:cs typeface="Calibri" pitchFamily="34" charset="-120"/>
-              </a:rPr>
-              <a:t>(doc IS JSON)</a:t>
-            </a:r>
-            <a:endParaRPr lang="en-US" sz="1200" dirty="0"/>
-          </a:p>
-        </p:txBody>
-      </p:sp>
-      <p:sp>
-        <p:nvSpPr>
-          <p:cNvPr id="10" name="Shape 8"/>
-          <p:cNvSpPr/>
-          <p:nvPr/>
-        </p:nvSpPr>
-        <p:spPr>
-          <a:xfrm>
-            <a:off x="457200" y="4206240"/>
-            <a:ext cx="5486400" cy="1965960"/>
-          </a:xfrm>
-          <a:prstGeom prst="roundRect">
-            <a:avLst>
-              <a:gd name="adj" fmla="val 2791"/>
-            </a:avLst>
-          </a:prstGeom>
-          <a:solidFill>
-            <a:srgbClr val="060D1E"/>
-          </a:solidFill>
-          <a:ln w="15875">
-            <a:solidFill>
-              <a:srgbClr val="F59E0B"/>
-            </a:solidFill>
-            <a:prstDash val="dash"/>
-          </a:ln>
-        </p:spPr>
-      </p:sp>
-      <p:sp>
-        <p:nvSpPr>
-          <p:cNvPr id="11" name="Text 9"/>
-          <p:cNvSpPr/>
-          <p:nvPr/>
-        </p:nvSpPr>
-        <p:spPr>
-          <a:xfrm>
-            <a:off x="640080" y="4389120"/>
-            <a:ext cx="5120640" cy="1600200"/>
-          </a:xfrm>
-          <a:prstGeom prst="rect">
-            <a:avLst/>
-          </a:prstGeom>
-          <a:noFill/>
-          <a:ln/>
-        </p:spPr>
-        <p:txBody>
-          <a:bodyPr wrap="square" lIns="0" tIns="0" rIns="0" bIns="0" rtlCol="0" anchor="ctr"/>
-          <a:lstStyle/>
-          <a:p>
-            <a:pPr algn="ctr" indent="0" marL="0">
-              <a:buNone/>
-            </a:pPr>
-            <a:r>
-              <a:rPr lang="en-US" sz="1200" b="1" dirty="0">
-                <a:solidFill>
-                  <a:srgbClr val="F59E0B"/>
-                </a:solidFill>
-                <a:latin typeface="Calibri" pitchFamily="34" charset="0"/>
-                <a:ea typeface="Calibri" pitchFamily="34" charset="-122"/>
-                <a:cs typeface="Calibri" pitchFamily="34" charset="-120"/>
-              </a:rPr>
-              <a:t>PRINT PENDENTE
-</a:t>
-            </a:r>
-            <a:endParaRPr lang="en-US" sz="1200" dirty="0"/>
-          </a:p>
-          <a:p>
-            <a:pPr algn="ctr" indent="0" marL="0">
-              <a:buNone/>
-            </a:pPr>
-            <a:r>
-              <a:rPr lang="en-US" sz="1050" dirty="0">
-                <a:solidFill>
-                  <a:srgbClr val="94A3B8"/>
-                </a:solidFill>
-                <a:latin typeface="Calibri" pitchFamily="34" charset="0"/>
-                <a:ea typeface="Calibri" pitchFamily="34" charset="-122"/>
-                <a:cs typeface="Calibri" pitchFamily="34" charset="-120"/>
-              </a:rPr>
-              <a:t>External Table LEITO360_POPULACAO_EXT</a:t>
-            </a:r>
-            <a:endParaRPr lang="en-US" sz="1200" dirty="0"/>
-          </a:p>
-          <a:p>
-            <a:pPr algn="ctr" indent="0" marL="0">
-              <a:buNone/>
-            </a:pPr>
-            <a:r>
-              <a:rPr lang="en-US" sz="1050" dirty="0">
-                <a:solidFill>
-                  <a:srgbClr val="94A3B8"/>
-                </a:solidFill>
-                <a:latin typeface="Calibri" pitchFamily="34" charset="0"/>
-                <a:ea typeface="Calibri" pitchFamily="34" charset="-122"/>
-                <a:cs typeface="Calibri" pitchFamily="34" charset="-120"/>
-              </a:rPr>
-              <a:t>(SELECT COUNT/SUM)</a:t>
-            </a:r>
-            <a:endParaRPr lang="en-US" sz="1200" dirty="0"/>
-          </a:p>
-        </p:txBody>
-      </p:sp>
-      <p:sp>
-        <p:nvSpPr>
-          <p:cNvPr id="12" name="Shape 10"/>
-          <p:cNvSpPr/>
-          <p:nvPr/>
-        </p:nvSpPr>
-        <p:spPr>
-          <a:xfrm>
-            <a:off x="6080760" y="4206240"/>
-            <a:ext cx="5486400" cy="1965960"/>
-          </a:xfrm>
-          <a:prstGeom prst="roundRect">
-            <a:avLst>
-              <a:gd name="adj" fmla="val 2791"/>
-            </a:avLst>
-          </a:prstGeom>
-          <a:solidFill>
-            <a:srgbClr val="060D1E"/>
-          </a:solidFill>
-          <a:ln w="15875">
-            <a:solidFill>
-              <a:srgbClr val="F59E0B"/>
-            </a:solidFill>
-            <a:prstDash val="dash"/>
-          </a:ln>
-        </p:spPr>
-      </p:sp>
-      <p:sp>
-        <p:nvSpPr>
-          <p:cNvPr id="13" name="Text 11"/>
-          <p:cNvSpPr/>
-          <p:nvPr/>
-        </p:nvSpPr>
-        <p:spPr>
-          <a:xfrm>
-            <a:off x="6263640" y="4389120"/>
-            <a:ext cx="5120640" cy="1600200"/>
-          </a:xfrm>
-          <a:prstGeom prst="rect">
-            <a:avLst/>
-          </a:prstGeom>
-          <a:noFill/>
-          <a:ln/>
-        </p:spPr>
-        <p:txBody>
-          <a:bodyPr wrap="square" lIns="0" tIns="0" rIns="0" bIns="0" rtlCol="0" anchor="ctr"/>
-          <a:lstStyle/>
-          <a:p>
-            <a:pPr algn="ctr" indent="0" marL="0">
-              <a:buNone/>
-            </a:pPr>
-            <a:r>
-              <a:rPr lang="en-US" sz="1200" b="1" dirty="0">
-                <a:solidFill>
-                  <a:srgbClr val="F59E0B"/>
-                </a:solidFill>
-                <a:latin typeface="Calibri" pitchFamily="34" charset="0"/>
-                <a:ea typeface="Calibri" pitchFamily="34" charset="-122"/>
-                <a:cs typeface="Calibri" pitchFamily="34" charset="-120"/>
-              </a:rPr>
-              <a:t>PRINT PENDENTE
-</a:t>
-            </a:r>
-            <a:endParaRPr lang="en-US" sz="1200" dirty="0"/>
-          </a:p>
-          <a:p>
-            <a:pPr algn="ctr" indent="0" marL="0">
-              <a:buNone/>
-            </a:pPr>
-            <a:r>
-              <a:rPr lang="en-US" sz="1050" dirty="0">
-                <a:solidFill>
-                  <a:srgbClr val="94A3B8"/>
-                </a:solidFill>
-                <a:latin typeface="Calibri" pitchFamily="34" charset="0"/>
-                <a:ea typeface="Calibri" pitchFamily="34" charset="-122"/>
-                <a:cs typeface="Calibri" pitchFamily="34" charset="-120"/>
-              </a:rPr>
-              <a:t>View VW_LEITO360_ANALITICO</a:t>
-            </a:r>
-            <a:endParaRPr lang="en-US" sz="1200" dirty="0"/>
-          </a:p>
-          <a:p>
-            <a:pPr algn="ctr" indent="0" marL="0">
-              <a:buNone/>
-            </a:pPr>
-            <a:r>
-              <a:rPr lang="en-US" sz="1050" dirty="0">
-                <a:solidFill>
-                  <a:srgbClr val="94A3B8"/>
-                </a:solidFill>
-                <a:latin typeface="Calibri" pitchFamily="34" charset="0"/>
-                <a:ea typeface="Calibri" pitchFamily="34" charset="-122"/>
-                <a:cs typeface="Calibri" pitchFamily="34" charset="-120"/>
-              </a:rPr>
-              <a:t>(consulta integrada)</a:t>
-            </a:r>
-            <a:endParaRPr lang="en-US" sz="1200" dirty="0"/>
-          </a:p>
-        </p:txBody>
-      </p:sp>
-      <p:sp>
-        <p:nvSpPr>
-          <p:cNvPr id="14" name="Text 12"/>
+              <a:t>Executado por MOVIESTREAM no SQL Worksheet do Database Actions. Ambiente temporário do LiveLabs (expira após a reserva) — usado apenas para gerar estas evidências, não é a infraestrutura definitiva do projeto.</a:t>
+            </a:r>
+            <a:endParaRPr lang="en-US" sz="900" dirty="0"/>
+          </a:p>
+        </p:txBody>
+      </p:sp>
+      <p:sp>
+        <p:nvSpPr>
+          <p:cNvPr id="8" name="Text 5"/>
           <p:cNvSpPr/>
           <p:nvPr/>
         </p:nvSpPr>
@@ -7736,7 +8229,7 @@
       </p:sp>
       <p:sp>
         <p:nvSpPr>
-          <p:cNvPr id="15" name="Text 13"/>
+          <p:cNvPr id="9" name="Text 6"/>
           <p:cNvSpPr/>
           <p:nvPr/>
         </p:nvSpPr>
@@ -7892,7 +8385,7 @@
                 <a:ea typeface="Cambria" pitchFamily="34" charset="-122"/>
                 <a:cs typeface="Cambria" pitchFamily="34" charset="-120"/>
               </a:rPr>
-              <a:t>Evidências visuais — Select AI (sem expor credenciais)</a:t>
+              <a:t>Select AI — perfil real criado, execução bloqueada por infraestrutura</a:t>
             </a:r>
             <a:endParaRPr lang="en-US" sz="2800" dirty="0"/>
           </a:p>
@@ -7931,7 +8424,7 @@
                 <a:ea typeface="Calibri" pitchFamily="34" charset="-122"/>
                 <a:cs typeface="Calibri" pitchFamily="34" charset="-120"/>
               </a:rPr>
-              <a:t>Print da configuração do perfil, de um prompt real e do SQL + resultado gerados.</a:t>
+              <a:t>Diagnóstico técnico completo em docs/evidencias/select_ai_perguntas.md — nada aqui foi inventado ou simulado.</a:t>
             </a:r>
             <a:endParaRPr lang="en-US" sz="1400" dirty="0"/>
           </a:p>
@@ -7946,22 +8439,29 @@
         <p:spPr>
           <a:xfrm>
             <a:off x="457200" y="2103120"/>
-            <a:ext cx="5486400" cy="1965960"/>
+            <a:ext cx="11247120" cy="914400"/>
           </a:xfrm>
           <a:prstGeom prst="roundRect">
             <a:avLst>
-              <a:gd name="adj" fmla="val 2791"/>
+              <a:gd name="adj" fmla="val 8000"/>
             </a:avLst>
           </a:prstGeom>
           <a:solidFill>
-            <a:srgbClr val="060D1E"/>
+            <a:srgbClr val="0F2A4A"/>
           </a:solidFill>
-          <a:ln w="15875">
+          <a:ln w="12700">
             <a:solidFill>
-              <a:srgbClr val="F59E0B"/>
+              <a:srgbClr val="1E3A5F"/>
             </a:solidFill>
-            <a:prstDash val="dash"/>
+            <a:prstDash val="solid"/>
           </a:ln>
+          <a:effectLst>
+            <a:outerShdw sx="100000" sy="100000" kx="0" ky="0" algn="bl" rotWithShape="0" blurRad="101600" dist="38100" dir="5400000">
+              <a:srgbClr val="000000">
+                <a:alpha val="35000"/>
+              </a:srgbClr>
+            </a:outerShdw>
+          </a:effectLst>
         </p:spPr>
       </p:sp>
       <p:sp>
@@ -7972,143 +8472,387 @@
         </p:nvSpPr>
         <p:spPr>
           <a:xfrm>
-            <a:off x="640080" y="2286000"/>
-            <a:ext cx="5120640" cy="1600200"/>
-          </a:xfrm>
-          <a:prstGeom prst="rect">
-            <a:avLst/>
-          </a:prstGeom>
-          <a:noFill/>
-          <a:ln/>
-        </p:spPr>
-        <p:txBody>
-          <a:bodyPr wrap="square" lIns="0" tIns="0" rIns="0" bIns="0" rtlCol="0" anchor="ctr"/>
-          <a:lstStyle/>
-          <a:p>
-            <a:pPr algn="ctr" indent="0" marL="0">
+            <a:off x="685800" y="2212848"/>
+            <a:ext cx="10789920" cy="274320"/>
+          </a:xfrm>
+          <a:prstGeom prst="rect">
+            <a:avLst/>
+          </a:prstGeom>
+          <a:noFill/>
+          <a:ln/>
+        </p:spPr>
+        <p:txBody>
+          <a:bodyPr wrap="square" lIns="0" tIns="0" rIns="0" bIns="0" rtlCol="0" anchor="ctr"/>
+          <a:lstStyle/>
+          <a:p>
+            <a:pPr indent="0" marL="0">
               <a:buNone/>
             </a:pPr>
             <a:r>
               <a:rPr lang="en-US" sz="1200" b="1" dirty="0">
                 <a:solidFill>
-                  <a:srgbClr val="F59E0B"/>
-                </a:solidFill>
-                <a:latin typeface="Calibri" pitchFamily="34" charset="0"/>
-                <a:ea typeface="Calibri" pitchFamily="34" charset="-122"/>
-                <a:cs typeface="Calibri" pitchFamily="34" charset="-120"/>
-              </a:rPr>
-              <a:t>PRINT PENDENTE
-</a:t>
+                  <a:srgbClr val="14B8A6"/>
+                </a:solidFill>
+                <a:latin typeface="Calibri" pitchFamily="34" charset="0"/>
+                <a:ea typeface="Calibri" pitchFamily="34" charset="-122"/>
+                <a:cs typeface="Calibri" pitchFamily="34" charset="-120"/>
+              </a:rPr>
+              <a:t>✓ Implementado e confirmado</a:t>
             </a:r>
             <a:endParaRPr lang="en-US" sz="1200" dirty="0"/>
           </a:p>
-          <a:p>
-            <a:pPr algn="ctr" indent="0" marL="0">
-              <a:buNone/>
-            </a:pPr>
-            <a:r>
-              <a:rPr lang="en-US" sz="1050" dirty="0">
-                <a:solidFill>
-                  <a:srgbClr val="94A3B8"/>
-                </a:solidFill>
-                <a:latin typeface="Calibri" pitchFamily="34" charset="0"/>
-                <a:ea typeface="Calibri" pitchFamily="34" charset="-122"/>
-                <a:cs typeface="Calibri" pitchFamily="34" charset="-120"/>
-              </a:rPr>
-              <a:t>Configuração do perfil LEITO360_AI</a:t>
-            </a:r>
-            <a:endParaRPr lang="en-US" sz="1200" dirty="0"/>
-          </a:p>
-          <a:p>
-            <a:pPr algn="ctr" indent="0" marL="0">
-              <a:buNone/>
-            </a:pPr>
-            <a:r>
-              <a:rPr lang="en-US" sz="1050" dirty="0">
-                <a:solidFill>
-                  <a:srgbClr val="94A3B8"/>
-                </a:solidFill>
-                <a:latin typeface="Calibri" pitchFamily="34" charset="0"/>
-                <a:ea typeface="Calibri" pitchFamily="34" charset="-122"/>
-                <a:cs typeface="Calibri" pitchFamily="34" charset="-120"/>
-              </a:rPr>
-              <a:t>(sem usuário/senha visíveis)</a:t>
-            </a:r>
-            <a:endParaRPr lang="en-US" sz="1200" dirty="0"/>
-          </a:p>
-        </p:txBody>
-      </p:sp>
-      <p:sp>
-        <p:nvSpPr>
-          <p:cNvPr id="8" name="Shape 6"/>
-          <p:cNvSpPr/>
-          <p:nvPr/>
-        </p:nvSpPr>
-        <p:spPr>
-          <a:xfrm>
-            <a:off x="6080760" y="2103120"/>
-            <a:ext cx="5486400" cy="1965960"/>
+        </p:txBody>
+      </p:sp>
+      <p:sp>
+        <p:nvSpPr>
+          <p:cNvPr id="8" name="Text 6"/>
+          <p:cNvSpPr/>
+          <p:nvPr/>
+        </p:nvSpPr>
+        <p:spPr>
+          <a:xfrm>
+            <a:off x="685800" y="2468880"/>
+            <a:ext cx="10789920" cy="502920"/>
+          </a:xfrm>
+          <a:prstGeom prst="rect">
+            <a:avLst/>
+          </a:prstGeom>
+          <a:noFill/>
+          <a:ln/>
+        </p:spPr>
+        <p:txBody>
+          <a:bodyPr wrap="square" lIns="0" tIns="0" rIns="0" bIns="0" rtlCol="0" anchor="ctr"/>
+          <a:lstStyle/>
+          <a:p>
+            <a:pPr indent="0" marL="0">
+              <a:buNone/>
+            </a:pPr>
+            <a:r>
+              <a:rPr lang="en-US" sz="1000" dirty="0">
+                <a:solidFill>
+                  <a:srgbClr val="EAF6F3"/>
+                </a:solidFill>
+                <a:latin typeface="Calibri" pitchFamily="34" charset="0"/>
+                <a:ea typeface="Calibri" pitchFamily="34" charset="-122"/>
+                <a:cs typeface="Calibri" pitchFamily="34" charset="-120"/>
+              </a:rPr>
+              <a:t>Perfil LEITO360_AI criado com sucesso (credencial nativa AI_CREDENTIAL indicada pela Task 2 do workshop, não OCI$RESOURCE_PRINCIPAL); DROP/CREATE_PROFILE respondem em ~1-2s; as 5 perguntas de negócio estão prontas em oracle/sql/08_select_ai_perguntas.sql.</a:t>
+            </a:r>
+            <a:endParaRPr lang="en-US" sz="1000" dirty="0"/>
+          </a:p>
+        </p:txBody>
+      </p:sp>
+      <p:sp>
+        <p:nvSpPr>
+          <p:cNvPr id="9" name="Shape 7"/>
+          <p:cNvSpPr/>
+          <p:nvPr/>
+        </p:nvSpPr>
+        <p:spPr>
+          <a:xfrm>
+            <a:off x="457200" y="3154680"/>
+            <a:ext cx="11247120" cy="2286000"/>
           </a:xfrm>
           <a:prstGeom prst="roundRect">
             <a:avLst>
-              <a:gd name="adj" fmla="val 2791"/>
+              <a:gd name="adj" fmla="val 3200"/>
             </a:avLst>
           </a:prstGeom>
           <a:solidFill>
-            <a:srgbClr val="060D1E"/>
+            <a:srgbClr val="2A1810"/>
           </a:solidFill>
-          <a:ln w="15875">
+          <a:ln w="12700">
             <a:solidFill>
-              <a:srgbClr val="F59E0B"/>
+              <a:srgbClr val="1E3A5F"/>
             </a:solidFill>
-            <a:prstDash val="dash"/>
+            <a:prstDash val="solid"/>
           </a:ln>
-        </p:spPr>
-      </p:sp>
-      <p:sp>
-        <p:nvSpPr>
-          <p:cNvPr id="9" name="Text 7"/>
-          <p:cNvSpPr/>
-          <p:nvPr/>
-        </p:nvSpPr>
-        <p:spPr>
-          <a:xfrm>
-            <a:off x="6263640" y="2286000"/>
-            <a:ext cx="5120640" cy="1600200"/>
-          </a:xfrm>
-          <a:prstGeom prst="rect">
-            <a:avLst/>
-          </a:prstGeom>
-          <a:noFill/>
-          <a:ln/>
-        </p:spPr>
-        <p:txBody>
-          <a:bodyPr wrap="square" lIns="0" tIns="0" rIns="0" bIns="0" rtlCol="0" anchor="ctr"/>
-          <a:lstStyle/>
-          <a:p>
-            <a:pPr algn="ctr" indent="0" marL="0">
+          <a:effectLst>
+            <a:outerShdw sx="100000" sy="100000" kx="0" ky="0" algn="bl" rotWithShape="0" blurRad="101600" dist="38100" dir="5400000">
+              <a:srgbClr val="000000">
+                <a:alpha val="35000"/>
+              </a:srgbClr>
+            </a:outerShdw>
+          </a:effectLst>
+        </p:spPr>
+      </p:sp>
+      <p:sp>
+        <p:nvSpPr>
+          <p:cNvPr id="10" name="Text 8"/>
+          <p:cNvSpPr/>
+          <p:nvPr/>
+        </p:nvSpPr>
+        <p:spPr>
+          <a:xfrm>
+            <a:off x="685800" y="3273552"/>
+            <a:ext cx="10789920" cy="274320"/>
+          </a:xfrm>
+          <a:prstGeom prst="rect">
+            <a:avLst/>
+          </a:prstGeom>
+          <a:noFill/>
+          <a:ln/>
+        </p:spPr>
+        <p:txBody>
+          <a:bodyPr wrap="square" lIns="0" tIns="0" rIns="0" bIns="0" rtlCol="0" anchor="ctr"/>
+          <a:lstStyle/>
+          <a:p>
+            <a:pPr indent="0" marL="0">
               <a:buNone/>
             </a:pPr>
             <a:r>
               <a:rPr lang="en-US" sz="1200" b="1" dirty="0">
                 <a:solidFill>
-                  <a:srgbClr val="F59E0B"/>
-                </a:solidFill>
-                <a:latin typeface="Calibri" pitchFamily="34" charset="0"/>
-                <a:ea typeface="Calibri" pitchFamily="34" charset="-122"/>
-                <a:cs typeface="Calibri" pitchFamily="34" charset="-120"/>
-              </a:rPr>
-              <a:t>PRINT PENDENTE
-</a:t>
+                  <a:srgbClr val="EF4444"/>
+                </a:solidFill>
+                <a:latin typeface="Calibri" pitchFamily="34" charset="0"/>
+                <a:ea typeface="Calibri" pitchFamily="34" charset="-122"/>
+                <a:cs typeface="Calibri" pitchFamily="34" charset="-120"/>
+              </a:rPr>
+              <a:t>✗ Bloqueado nesta execução</a:t>
             </a:r>
             <a:endParaRPr lang="en-US" sz="1200" dirty="0"/>
           </a:p>
-          <a:p>
-            <a:pPr algn="ctr" indent="0" marL="0">
-              <a:buNone/>
-            </a:pPr>
-            <a:r>
-              <a:rPr lang="en-US" sz="1050" dirty="0">
+        </p:txBody>
+      </p:sp>
+      <p:sp>
+        <p:nvSpPr>
+          <p:cNvPr id="11" name="Text 9"/>
+          <p:cNvSpPr/>
+          <p:nvPr/>
+        </p:nvSpPr>
+        <p:spPr>
+          <a:xfrm>
+            <a:off x="685800" y="3611880"/>
+            <a:ext cx="10789920" cy="457200"/>
+          </a:xfrm>
+          <a:prstGeom prst="rect">
+            <a:avLst/>
+          </a:prstGeom>
+          <a:noFill/>
+          <a:ln/>
+        </p:spPr>
+        <p:txBody>
+          <a:bodyPr wrap="square" lIns="0" tIns="0" rIns="0" bIns="0" rtlCol="0" anchor="ctr"/>
+          <a:lstStyle/>
+          <a:p>
+            <a:pPr indent="0" marL="0">
+              <a:buNone/>
+            </a:pPr>
+            <a:r>
+              <a:rPr lang="en-US" sz="1000" dirty="0">
+                <a:solidFill>
+                  <a:srgbClr val="EF4444"/>
+                </a:solidFill>
+                <a:latin typeface="Calibri" pitchFamily="34" charset="0"/>
+                <a:ea typeface="Calibri" pitchFamily="34" charset="-122"/>
+                <a:cs typeface="Calibri" pitchFamily="34" charset="-120"/>
+              </a:rPr>
+              <a:t>• </a:t>
+            </a:r>
+            <a:pPr indent="0" marL="0">
+              <a:buNone/>
+            </a:pPr>
+            <a:r>
+              <a:rPr lang="en-US" sz="1000" dirty="0">
+                <a:solidFill>
+                  <a:srgbClr val="EAF6F3"/>
+                </a:solidFill>
+                <a:latin typeface="Calibri" pitchFamily="34" charset="0"/>
+                <a:ea typeface="Calibri" pitchFamily="34" charset="-122"/>
+                <a:cs typeface="Calibri" pitchFamily="34" charset="-120"/>
+              </a:rPr>
+              <a:t>Toda chamada a DBMS_CLOUD_AI.GENERATE (chat, showsql) ficou pendente 3-10 min e falhou — testado 4x, em 2 worksheets, com prompts diferentes.</a:t>
+            </a:r>
+            <a:endParaRPr lang="en-US" sz="1000" dirty="0"/>
+          </a:p>
+        </p:txBody>
+      </p:sp>
+      <p:sp>
+        <p:nvSpPr>
+          <p:cNvPr id="12" name="Text 10"/>
+          <p:cNvSpPr/>
+          <p:nvPr/>
+        </p:nvSpPr>
+        <p:spPr>
+          <a:xfrm>
+            <a:off x="685800" y="4050792"/>
+            <a:ext cx="10789920" cy="457200"/>
+          </a:xfrm>
+          <a:prstGeom prst="rect">
+            <a:avLst/>
+          </a:prstGeom>
+          <a:noFill/>
+          <a:ln/>
+        </p:spPr>
+        <p:txBody>
+          <a:bodyPr wrap="square" lIns="0" tIns="0" rIns="0" bIns="0" rtlCol="0" anchor="ctr"/>
+          <a:lstStyle/>
+          <a:p>
+            <a:pPr indent="0" marL="0">
+              <a:buNone/>
+            </a:pPr>
+            <a:r>
+              <a:rPr lang="en-US" sz="1000" dirty="0">
+                <a:solidFill>
+                  <a:srgbClr val="EF4444"/>
+                </a:solidFill>
+                <a:latin typeface="Calibri" pitchFamily="34" charset="0"/>
+                <a:ea typeface="Calibri" pitchFamily="34" charset="-122"/>
+                <a:cs typeface="Calibri" pitchFamily="34" charset="-120"/>
+              </a:rPr>
+              <a:t>• </a:t>
+            </a:r>
+            <a:pPr indent="0" marL="0">
+              <a:buNone/>
+            </a:pPr>
+            <a:r>
+              <a:rPr lang="en-US" sz="1000" dirty="0">
+                <a:solidFill>
+                  <a:srgbClr val="EAF6F3"/>
+                </a:solidFill>
+                <a:latin typeface="Calibri" pitchFamily="34" charset="0"/>
+                <a:ea typeface="Calibri" pitchFamily="34" charset="-122"/>
+                <a:cs typeface="Calibri" pitchFamily="34" charset="-120"/>
+              </a:rPr>
+              <a:t>1ª tentativa (credencial OCI$RESOURCE_PRINCIPAL): erro imediato ORA-20404 com URL contendo "my$cloud_domain" não substituído — bug de configuração do sandbox, não do LEITO360.</a:t>
+            </a:r>
+            <a:endParaRPr lang="en-US" sz="1000" dirty="0"/>
+          </a:p>
+        </p:txBody>
+      </p:sp>
+      <p:sp>
+        <p:nvSpPr>
+          <p:cNvPr id="13" name="Text 11"/>
+          <p:cNvSpPr/>
+          <p:nvPr/>
+        </p:nvSpPr>
+        <p:spPr>
+          <a:xfrm>
+            <a:off x="685800" y="4489704"/>
+            <a:ext cx="10789920" cy="457200"/>
+          </a:xfrm>
+          <a:prstGeom prst="rect">
+            <a:avLst/>
+          </a:prstGeom>
+          <a:noFill/>
+          <a:ln/>
+        </p:spPr>
+        <p:txBody>
+          <a:bodyPr wrap="square" lIns="0" tIns="0" rIns="0" bIns="0" rtlCol="0" anchor="ctr"/>
+          <a:lstStyle/>
+          <a:p>
+            <a:pPr indent="0" marL="0">
+              <a:buNone/>
+            </a:pPr>
+            <a:r>
+              <a:rPr lang="en-US" sz="1000" dirty="0">
+                <a:solidFill>
+                  <a:srgbClr val="EF4444"/>
+                </a:solidFill>
+                <a:latin typeface="Calibri" pitchFamily="34" charset="0"/>
+                <a:ea typeface="Calibri" pitchFamily="34" charset="-122"/>
+                <a:cs typeface="Calibri" pitchFamily="34" charset="-120"/>
+              </a:rPr>
+              <a:t>• </a:t>
+            </a:r>
+            <a:pPr indent="0" marL="0">
+              <a:buNone/>
+            </a:pPr>
+            <a:r>
+              <a:rPr lang="en-US" sz="1000" dirty="0">
+                <a:solidFill>
+                  <a:srgbClr val="EAF6F3"/>
+                </a:solidFill>
+                <a:latin typeface="Calibri" pitchFamily="34" charset="0"/>
+                <a:ea typeface="Calibri" pitchFamily="34" charset="-122"/>
+                <a:cs typeface="Calibri" pitchFamily="34" charset="-120"/>
+              </a:rPr>
+              <a:t>2ª tentativa (credencial correta AI_CREDENTIAL, indicada pelo próprio workshop): sem erro imediato, mas timeout após vários minutos, sem corpo de erro recuperável.</a:t>
+            </a:r>
+            <a:endParaRPr lang="en-US" sz="1000" dirty="0"/>
+          </a:p>
+        </p:txBody>
+      </p:sp>
+      <p:sp>
+        <p:nvSpPr>
+          <p:cNvPr id="14" name="Text 12"/>
+          <p:cNvSpPr/>
+          <p:nvPr/>
+        </p:nvSpPr>
+        <p:spPr>
+          <a:xfrm>
+            <a:off x="685800" y="4928616"/>
+            <a:ext cx="10789920" cy="457200"/>
+          </a:xfrm>
+          <a:prstGeom prst="rect">
+            <a:avLst/>
+          </a:prstGeom>
+          <a:noFill/>
+          <a:ln/>
+        </p:spPr>
+        <p:txBody>
+          <a:bodyPr wrap="square" lIns="0" tIns="0" rIns="0" bIns="0" rtlCol="0" anchor="ctr"/>
+          <a:lstStyle/>
+          <a:p>
+            <a:pPr indent="0" marL="0">
+              <a:buNone/>
+            </a:pPr>
+            <a:r>
+              <a:rPr lang="en-US" sz="1000" dirty="0">
+                <a:solidFill>
+                  <a:srgbClr val="EF4444"/>
+                </a:solidFill>
+                <a:latin typeface="Calibri" pitchFamily="34" charset="0"/>
+                <a:ea typeface="Calibri" pitchFamily="34" charset="-122"/>
+                <a:cs typeface="Calibri" pitchFamily="34" charset="-120"/>
+              </a:rPr>
+              <a:t>• </a:t>
+            </a:r>
+            <a:pPr indent="0" marL="0">
+              <a:buNone/>
+            </a:pPr>
+            <a:r>
+              <a:rPr lang="en-US" sz="1000" dirty="0">
+                <a:solidFill>
+                  <a:srgbClr val="EAF6F3"/>
+                </a:solidFill>
+                <a:latin typeface="Calibri" pitchFamily="34" charset="0"/>
+                <a:ea typeface="Calibri" pitchFamily="34" charset="-122"/>
+                <a:cs typeface="Calibri" pitchFamily="34" charset="-120"/>
+              </a:rPr>
+              <a:t>Uma consulta SQL comum (SELECT 1 FROM dual) no mesmo worksheet respondeu em milissegundos — confirma que o banco está saudável; o problema é isolado ao serviço de inferência do OCI Generative AI.</a:t>
+            </a:r>
+            <a:endParaRPr lang="en-US" sz="1000" dirty="0"/>
+          </a:p>
+        </p:txBody>
+      </p:sp>
+      <p:sp>
+        <p:nvSpPr>
+          <p:cNvPr id="15" name="Text 13"/>
+          <p:cNvSpPr/>
+          <p:nvPr/>
+        </p:nvSpPr>
+        <p:spPr>
+          <a:xfrm>
+            <a:off x="457200" y="5577840"/>
+            <a:ext cx="11247120" cy="365760"/>
+          </a:xfrm>
+          <a:prstGeom prst="rect">
+            <a:avLst/>
+          </a:prstGeom>
+          <a:noFill/>
+          <a:ln/>
+        </p:spPr>
+        <p:txBody>
+          <a:bodyPr wrap="square" lIns="0" tIns="0" rIns="0" bIns="0" rtlCol="0" anchor="ctr"/>
+          <a:lstStyle/>
+          <a:p>
+            <a:pPr indent="0" marL="0">
+              <a:buNone/>
+            </a:pPr>
+            <a:r>
+              <a:rPr lang="en-US" sz="1000" i="1" dirty="0">
                 <a:solidFill>
                   <a:srgbClr val="94A3B8"/>
                 </a:solidFill>
@@ -8116,200 +8860,15 @@
                 <a:ea typeface="Calibri" pitchFamily="34" charset="-122"/>
                 <a:cs typeface="Calibri" pitchFamily="34" charset="-120"/>
               </a:rPr>
-              <a:t>Prompt real (uma das 5 perguntas)</a:t>
-            </a:r>
-            <a:endParaRPr lang="en-US" sz="1200" dirty="0"/>
-          </a:p>
-          <a:p>
-            <a:pPr algn="ctr" indent="0" marL="0">
-              <a:buNone/>
-            </a:pPr>
-            <a:r>
-              <a:rPr lang="en-US" sz="1050" dirty="0">
-                <a:solidFill>
-                  <a:srgbClr val="94A3B8"/>
-                </a:solidFill>
-                <a:latin typeface="Calibri" pitchFamily="34" charset="0"/>
-                <a:ea typeface="Calibri" pitchFamily="34" charset="-122"/>
-                <a:cs typeface="Calibri" pitchFamily="34" charset="-120"/>
-              </a:rPr>
-              <a:t>+ ação SHOWSQL</a:t>
-            </a:r>
-            <a:endParaRPr lang="en-US" sz="1200" dirty="0"/>
-          </a:p>
-        </p:txBody>
-      </p:sp>
-      <p:sp>
-        <p:nvSpPr>
-          <p:cNvPr id="10" name="Shape 8"/>
-          <p:cNvSpPr/>
-          <p:nvPr/>
-        </p:nvSpPr>
-        <p:spPr>
-          <a:xfrm>
-            <a:off x="457200" y="4206240"/>
-            <a:ext cx="5486400" cy="1965960"/>
-          </a:xfrm>
-          <a:prstGeom prst="roundRect">
-            <a:avLst>
-              <a:gd name="adj" fmla="val 2791"/>
-            </a:avLst>
-          </a:prstGeom>
-          <a:solidFill>
-            <a:srgbClr val="060D1E"/>
-          </a:solidFill>
-          <a:ln w="15875">
-            <a:solidFill>
-              <a:srgbClr val="F59E0B"/>
-            </a:solidFill>
-            <a:prstDash val="dash"/>
-          </a:ln>
-        </p:spPr>
-      </p:sp>
-      <p:sp>
-        <p:nvSpPr>
-          <p:cNvPr id="11" name="Text 9"/>
-          <p:cNvSpPr/>
-          <p:nvPr/>
-        </p:nvSpPr>
-        <p:spPr>
-          <a:xfrm>
-            <a:off x="640080" y="4389120"/>
-            <a:ext cx="5120640" cy="1600200"/>
-          </a:xfrm>
-          <a:prstGeom prst="rect">
-            <a:avLst/>
-          </a:prstGeom>
-          <a:noFill/>
-          <a:ln/>
-        </p:spPr>
-        <p:txBody>
-          <a:bodyPr wrap="square" lIns="0" tIns="0" rIns="0" bIns="0" rtlCol="0" anchor="ctr"/>
-          <a:lstStyle/>
-          <a:p>
-            <a:pPr algn="ctr" indent="0" marL="0">
-              <a:buNone/>
-            </a:pPr>
-            <a:r>
-              <a:rPr lang="en-US" sz="1200" b="1" dirty="0">
-                <a:solidFill>
-                  <a:srgbClr val="F59E0B"/>
-                </a:solidFill>
-                <a:latin typeface="Calibri" pitchFamily="34" charset="0"/>
-                <a:ea typeface="Calibri" pitchFamily="34" charset="-122"/>
-                <a:cs typeface="Calibri" pitchFamily="34" charset="-120"/>
-              </a:rPr>
-              <a:t>PRINT PENDENTE
-</a:t>
-            </a:r>
-            <a:endParaRPr lang="en-US" sz="1200" dirty="0"/>
-          </a:p>
-          <a:p>
-            <a:pPr algn="ctr" indent="0" marL="0">
-              <a:buNone/>
-            </a:pPr>
-            <a:r>
-              <a:rPr lang="en-US" sz="1050" dirty="0">
-                <a:solidFill>
-                  <a:srgbClr val="94A3B8"/>
-                </a:solidFill>
-                <a:latin typeface="Calibri" pitchFamily="34" charset="0"/>
-                <a:ea typeface="Calibri" pitchFamily="34" charset="-122"/>
-                <a:cs typeface="Calibri" pitchFamily="34" charset="-120"/>
-              </a:rPr>
-              <a:t>SQL gerado pelo Select AI</a:t>
-            </a:r>
-            <a:endParaRPr lang="en-US" sz="1200" dirty="0"/>
-          </a:p>
-        </p:txBody>
-      </p:sp>
-      <p:sp>
-        <p:nvSpPr>
-          <p:cNvPr id="12" name="Shape 10"/>
-          <p:cNvSpPr/>
-          <p:nvPr/>
-        </p:nvSpPr>
-        <p:spPr>
-          <a:xfrm>
-            <a:off x="6080760" y="4206240"/>
-            <a:ext cx="5486400" cy="1965960"/>
-          </a:xfrm>
-          <a:prstGeom prst="roundRect">
-            <a:avLst>
-              <a:gd name="adj" fmla="val 2791"/>
-            </a:avLst>
-          </a:prstGeom>
-          <a:solidFill>
-            <a:srgbClr val="060D1E"/>
-          </a:solidFill>
-          <a:ln w="15875">
-            <a:solidFill>
-              <a:srgbClr val="F59E0B"/>
-            </a:solidFill>
-            <a:prstDash val="dash"/>
-          </a:ln>
-        </p:spPr>
-      </p:sp>
-      <p:sp>
-        <p:nvSpPr>
-          <p:cNvPr id="13" name="Text 11"/>
-          <p:cNvSpPr/>
-          <p:nvPr/>
-        </p:nvSpPr>
-        <p:spPr>
-          <a:xfrm>
-            <a:off x="6263640" y="4389120"/>
-            <a:ext cx="5120640" cy="1600200"/>
-          </a:xfrm>
-          <a:prstGeom prst="rect">
-            <a:avLst/>
-          </a:prstGeom>
-          <a:noFill/>
-          <a:ln/>
-        </p:spPr>
-        <p:txBody>
-          <a:bodyPr wrap="square" lIns="0" tIns="0" rIns="0" bIns="0" rtlCol="0" anchor="ctr"/>
-          <a:lstStyle/>
-          <a:p>
-            <a:pPr algn="ctr" indent="0" marL="0">
-              <a:buNone/>
-            </a:pPr>
-            <a:r>
-              <a:rPr lang="en-US" sz="1200" b="1" dirty="0">
-                <a:solidFill>
-                  <a:srgbClr val="F59E0B"/>
-                </a:solidFill>
-                <a:latin typeface="Calibri" pitchFamily="34" charset="0"/>
-                <a:ea typeface="Calibri" pitchFamily="34" charset="-122"/>
-                <a:cs typeface="Calibri" pitchFamily="34" charset="-120"/>
-              </a:rPr>
-              <a:t>PRINT PENDENTE
-</a:t>
-            </a:r>
-            <a:endParaRPr lang="en-US" sz="1200" dirty="0"/>
-          </a:p>
-          <a:p>
-            <a:pPr algn="ctr" indent="0" marL="0">
-              <a:buNone/>
-            </a:pPr>
-            <a:r>
-              <a:rPr lang="en-US" sz="1050" dirty="0">
-                <a:solidFill>
-                  <a:srgbClr val="94A3B8"/>
-                </a:solidFill>
-                <a:latin typeface="Calibri" pitchFamily="34" charset="0"/>
-                <a:ea typeface="Calibri" pitchFamily="34" charset="-122"/>
-                <a:cs typeface="Calibri" pitchFamily="34" charset="-120"/>
-              </a:rPr>
-              <a:t>Resultado da execução (RUNSQL)</a:t>
-            </a:r>
-            <a:endParaRPr lang="en-US" sz="1200" dirty="0"/>
-          </a:p>
-        </p:txBody>
-      </p:sp>
-      <p:sp>
-        <p:nvSpPr>
-          <p:cNvPr id="14" name="Text 12"/>
+              <a:t>Próximo passo: reexecutar em um ambiente com OCI Generative AI confirmadamente saudável (tenancy própria ou nova reserva de sandbox) e preencher as evidências reais das 5 perguntas.</a:t>
+            </a:r>
+            <a:endParaRPr lang="en-US" sz="1000" dirty="0"/>
+          </a:p>
+        </p:txBody>
+      </p:sp>
+      <p:sp>
+        <p:nvSpPr>
+          <p:cNvPr id="16" name="Text 14"/>
           <p:cNvSpPr/>
           <p:nvPr/>
         </p:nvSpPr>
@@ -8348,7 +8907,7 @@
       </p:sp>
       <p:sp>
         <p:nvSpPr>
-          <p:cNvPr id="15" name="Text 13"/>
+          <p:cNvPr id="17" name="Text 15"/>
           <p:cNvSpPr/>
           <p:nvPr/>
         </p:nvSpPr>
@@ -9344,15 +9903,15 @@
               <a:buNone/>
             </a:pPr>
             <a:r>
-              <a:rPr lang="en-US" sz="1100" i="1" dirty="0">
-                <a:solidFill>
-                  <a:srgbClr val="F59E0B"/>
-                </a:solidFill>
-                <a:latin typeface="Calibri" pitchFamily="34" charset="0"/>
-                <a:ea typeface="Calibri" pitchFamily="34" charset="-122"/>
-                <a:cs typeface="Calibri" pitchFamily="34" charset="-120"/>
-              </a:rPr>
-              <a:t>[preencher após publicar no GitHub Pages]</a:t>
+              <a:rPr lang="en-US" sz="1100" dirty="0">
+                <a:solidFill>
+                  <a:srgbClr val="EAF6F3"/>
+                </a:solidFill>
+                <a:latin typeface="Courier New" pitchFamily="34" charset="0"/>
+                <a:ea typeface="Courier New" pitchFamily="34" charset="-122"/>
+                <a:cs typeface="Courier New" pitchFamily="34" charset="-120"/>
+              </a:rPr>
+              <a:t>gabriellive1817-stack.github.io/Leito_360</a:t>
             </a:r>
             <a:endParaRPr lang="en-US" sz="1100" dirty="0"/>
           </a:p>
@@ -20305,7 +20864,7 @@
                 <a:ea typeface="Calibri" pitchFamily="34" charset="-122"/>
                 <a:cs typeface="Calibri" pitchFamily="34" charset="-120"/>
               </a:rPr>
-              <a:t>Capturar em: pnpm dev → tela Visão Executiva</a:t>
+              <a:t>Capturar em: gabriellive1817-stack.github.io/Leito_360</a:t>
             </a:r>
             <a:endParaRPr lang="en-US" sz="1200" dirty="0"/>
           </a:p>
@@ -20322,7 +20881,7 @@
                 <a:ea typeface="Calibri" pitchFamily="34" charset="-122"/>
                 <a:cs typeface="Calibri" pitchFamily="34" charset="-120"/>
               </a:rPr>
-              <a:t>(filtro de competência + região + UF selecionada)</a:t>
+              <a:t>(tela Visão Executiva — filtro de competência + região + UF selecionada)</a:t>
             </a:r>
             <a:endParaRPr lang="en-US" sz="1200" dirty="0"/>
           </a:p>
@@ -20648,7 +21207,7 @@
                 <a:ea typeface="Calibri" pitchFamily="34" charset="-122"/>
                 <a:cs typeface="Calibri" pitchFamily="34" charset="-120"/>
               </a:rPr>
-              <a:t>Capturar em: pnpm dev → tela Explorador Analítico</a:t>
+              <a:t>Capturar em: gabriellive1817-stack.github.io/Leito_360</a:t>
             </a:r>
             <a:endParaRPr lang="en-US" sz="1200" dirty="0"/>
           </a:p>
@@ -20665,7 +21224,7 @@
                 <a:ea typeface="Calibri" pitchFamily="34" charset="-122"/>
                 <a:cs typeface="Calibri" pitchFamily="34" charset="-120"/>
               </a:rPr>
-              <a:t>(tabela ordenada + painel de fontes/limitações)</a:t>
+              <a:t>(tela Explorador Analítico — tabela ordenada + painel de fontes/limitações)</a:t>
             </a:r>
             <a:endParaRPr lang="en-US" sz="1200" dirty="0"/>
           </a:p>

</xml_diff>

<commit_message>
Marca o vídeo pitch como entregue e centraliza onde colar o link
O vídeo foi gravado com demonstração ao vivo do dashboard publicado e do
Oracle Database Actions, incluindo o Select AI respondendo. Com isso os seis
itens do slide 10 ficam em 100%.

Cria a seção Entregáveis no topo do README, que até agora não existia, e
deixa um único lugar marcado em cada artefato para o link do YouTube: a linha
em dourado "COLE O LINK AQUI" no slide 17 e a linha correspondente no README.
O roteiro passa a apontar os dois lugares numa tabela, com o aviso de que
regerar o PPTX por script sobrescreve o link se ele não for reescrito também
em build_pptx.js.

Co-Authored-By: Claude Opus 5 <noreply@anthropic.com>
</commit_message>
<xml_diff>
--- a/EC_Sprint_2_1TSCOA_EvidenciasConstrucao_LEITO360_GRUPO61.pptx
+++ b/EC_Sprint_2_1TSCOA_EvidenciasConstrucao_LEITO360_GRUPO61.pptx
@@ -4331,7 +4331,7 @@
                 <a:ea typeface="Calibri" pitchFamily="34" charset="-122"/>
                 <a:cs typeface="Calibri" pitchFamily="34" charset="-120"/>
               </a:rPr>
-              <a:t>Vídeo pitch (gravado; edição e publicação com outro integrante)</a:t>
+              <a:t>Vídeo pitch (gravado, com demonstração ao vivo do Oracle e do dashboard)</a:t>
             </a:r>
             <a:endParaRPr lang="en-US" sz="1200" dirty="0"/>
           </a:p>
@@ -4368,7 +4368,7 @@
         <p:spPr>
           <a:xfrm>
             <a:off x="6903720" y="5879592"/>
-            <a:ext cx="1664208" cy="219456"/>
+            <a:ext cx="2377440" cy="219456"/>
           </a:xfrm>
           <a:prstGeom prst="roundRect">
             <a:avLst>
@@ -4376,7 +4376,7 @@
             </a:avLst>
           </a:prstGeom>
           <a:solidFill>
-            <a:srgbClr val="F59E0B"/>
+            <a:srgbClr val="14B8A6"/>
           </a:solidFill>
           <a:ln/>
         </p:spPr>
@@ -4408,13 +4408,13 @@
             <a:r>
               <a:rPr lang="en-US" sz="1100" b="1" dirty="0">
                 <a:solidFill>
-                  <a:srgbClr val="F59E0B"/>
-                </a:solidFill>
-                <a:latin typeface="Calibri" pitchFamily="34" charset="0"/>
-                <a:ea typeface="Calibri" pitchFamily="34" charset="-122"/>
-                <a:cs typeface="Calibri" pitchFamily="34" charset="-120"/>
-              </a:rPr>
-              <a:t>70%</a:t>
+                  <a:srgbClr val="14B8A6"/>
+                </a:solidFill>
+                <a:latin typeface="Calibri" pitchFamily="34" charset="0"/>
+                <a:ea typeface="Calibri" pitchFamily="34" charset="-122"/>
+                <a:cs typeface="Calibri" pitchFamily="34" charset="-120"/>
+              </a:rPr>
+              <a:t>100%</a:t>
             </a:r>
             <a:endParaRPr lang="en-US" sz="1100" dirty="0"/>
           </a:p>
@@ -4443,7 +4443,7 @@
           </a:solidFill>
           <a:ln w="12700">
             <a:solidFill>
-              <a:srgbClr val="F59E0B"/>
+              <a:srgbClr val="14B8A6"/>
             </a:solidFill>
             <a:prstDash val="solid"/>
           </a:ln>
@@ -4476,13 +4476,13 @@
             <a:r>
               <a:rPr lang="en-US" sz="1000" b="1" dirty="0">
                 <a:solidFill>
-                  <a:srgbClr val="F59E0B"/>
-                </a:solidFill>
-                <a:latin typeface="Calibri" pitchFamily="34" charset="0"/>
-                <a:ea typeface="Calibri" pitchFamily="34" charset="-122"/>
-                <a:cs typeface="Calibri" pitchFamily="34" charset="-120"/>
-              </a:rPr>
-              <a:t>Em produção</a:t>
+                  <a:srgbClr val="14B8A6"/>
+                </a:solidFill>
+                <a:latin typeface="Calibri" pitchFamily="34" charset="0"/>
+                <a:ea typeface="Calibri" pitchFamily="34" charset="-122"/>
+                <a:cs typeface="Calibri" pitchFamily="34" charset="-120"/>
+              </a:rPr>
+              <a:t>Implementado</a:t>
             </a:r>
             <a:endParaRPr lang="en-US" sz="1000" dirty="0"/>
           </a:p>
@@ -10688,7 +10688,7 @@
                 <a:ea typeface="Calibri" pitchFamily="34" charset="-122"/>
                 <a:cs typeface="Calibri" pitchFamily="34" charset="-120"/>
               </a:rPr>
-              <a:t>Até 5 minutos — plano de gravação em docs/roteiro_pitch/roteiro.md e o texto falado, dividido por integrante, em texto_pitch.md.</a:t>
+              <a:t>Gravado, com demonstração ao vivo do dashboard publicado e do Oracle Database Actions. Plano em docs/roteiro_pitch/roteiro.md e o texto falado, dividido por integrante, em texto_pitch.md.</a:t>
             </a:r>
             <a:endParaRPr lang="en-US" sz="1400" dirty="0"/>
           </a:p>
@@ -11625,7 +11625,21 @@
               <a:buNone/>
             </a:pPr>
             <a:r>
-              <a:rPr lang="en-US" sz="1200" i="1" dirty="0">
+              <a:rPr lang="en-US" sz="1300" b="1" dirty="0">
+                <a:solidFill>
+                  <a:srgbClr val="EAF6F3"/>
+                </a:solidFill>
+                <a:latin typeface="Calibri" pitchFamily="34" charset="0"/>
+                <a:ea typeface="Calibri" pitchFamily="34" charset="-122"/>
+                <a:cs typeface="Calibri" pitchFamily="34" charset="-120"/>
+              </a:rPr>
+              <a:t>Link do vídeo (YouTube): </a:t>
+            </a:r>
+            <a:pPr indent="0" marL="0">
+              <a:buNone/>
+            </a:pPr>
+            <a:r>
+              <a:rPr lang="en-US" sz="1300" b="1" dirty="0">
                 <a:solidFill>
                   <a:srgbClr val="F59E0B"/>
                 </a:solidFill>
@@ -11633,9 +11647,9 @@
                 <a:ea typeface="Calibri" pitchFamily="34" charset="-122"/>
                 <a:cs typeface="Calibri" pitchFamily="34" charset="-120"/>
               </a:rPr>
-              <a:t>Link do vídeo (YouTube): [preencher após gravação e publicação]</a:t>
-            </a:r>
-            <a:endParaRPr lang="en-US" sz="1200" dirty="0"/>
+              <a:t>COLE O LINK AQUI</a:t>
+            </a:r>
+            <a:endParaRPr lang="en-US" sz="1300" dirty="0"/>
           </a:p>
         </p:txBody>
       </p:sp>
@@ -12421,7 +12435,7 @@
                 <a:ea typeface="Calibri" pitchFamily="34" charset="-122"/>
                 <a:cs typeface="Calibri" pitchFamily="34" charset="-120"/>
               </a:rPr>
-              <a:t>• Publicar o vídeo pitch (já gravado)</a:t>
+              <a:t>• Transcrever as saídas das perguntas 2 a 5 do Select AI</a:t>
             </a:r>
             <a:endParaRPr lang="en-US" sz="1100" dirty="0"/>
           </a:p>

</xml_diff>